<commit_message>
Update presentation and project report: consolidate Phase 2 end-sem roadmap and integrate comparative findings from Elsevier 2025
</commit_message>
<xml_diff>
--- a/Mid_Sem_Presentation_CSPC401.pptx
+++ b/Mid_Sem_Presentation_CSPC401.pptx
@@ -3417,7 +3417,7 @@
               </a:defRPr>
             </a:pPr>
             <a:r>
-              <a:t>5. Phase 2 Architecture: Proposed Digital GIS Spatial Mapping (Mid-Sem 2)</a:t>
+              <a:t>4. Progress Achieved: Digital GIS Spatial Mapping Prototype (Phase 1)</a:t>
             </a:r>
           </a:p>
         </p:txBody>
@@ -3543,7 +3543,7 @@
               </a:defRPr>
             </a:pPr>
             <a:r>
-              <a:t>PROPOSED GIS SPATIAL TILING PIPELINE (SCHEDULED FOR MID-SEM 2)</a:t>
+              <a:t>OPERATIONAL GIS SPATIAL TILING PIPELINE &amp; INTERACTIVE DASHBOARD</a:t>
             </a:r>
           </a:p>
           <a:p>
@@ -3583,7 +3583,7 @@
               </a:spcAft>
             </a:pPr>
             <a:r>
-              <a:t>• Mid-Sem 2 Scheduled Deliverable: Demonstration of whole-field spatial GIS tiling, acreage statistics, and interactive clickable grid dashboards across diverse agro-climatic zones.</a:t>
+              <a:t>• Delivered Phase 1 Asset: Functional GIS spatial orthomosaic tiler generating high-res zoning heatmaps (PNG) and interactive Leaflet HTML web dashboards across diverse agro-climatic zones.</a:t>
             </a:r>
           </a:p>
         </p:txBody>
@@ -4063,7 +4063,7 @@
               </a:defRPr>
             </a:pPr>
             <a:r>
-              <a:t>5. Future Work &amp; Phased Implementation Roadmap</a:t>
+              <a:t>5. Project Implementation Roadmap: Phase 1 Delivery &amp; Final Phase Scope</a:t>
             </a:r>
           </a:p>
         </p:txBody>
@@ -4121,8 +4121,8 @@
         </p:nvSpPr>
         <p:spPr>
           <a:xfrm>
-            <a:off x="731520" y="1600200"/>
-            <a:ext cx="10728655" cy="1051560"/>
+            <a:off x="731520" y="1554480"/>
+            <a:ext cx="5166360" cy="4663440"/>
           </a:xfrm>
           <a:prstGeom prst="roundRect">
             <a:avLst/>
@@ -4155,34 +4155,134 @@
           <a:lstStyle/>
           <a:p>
             <a:pPr algn="ctr">
-              <a:defRPr b="1" sz="1200">
-                <a:solidFill>
-                  <a:srgbClr val="1E824C"/>
-                </a:solidFill>
-              </a:defRPr>
-            </a:pPr>
-            <a:r>
-              <a:t>Phase 1: Foundation &amp; Diagnostic AI (COMPLETED - Mid-Sem 1)  [Aug – Oct 2026]</a:t>
+              <a:defRPr b="1" sz="1300">
+                <a:solidFill>
+                  <a:srgbClr val="1E3A8A"/>
+                </a:solidFill>
+              </a:defRPr>
+            </a:pPr>
+            <a:r>
+              <a:t>PHASE 1: Foundation &amp; Diagnostic AI (DELIVERED — Mid-Sem 1)</a:t>
             </a:r>
           </a:p>
           <a:p>
             <a:pPr>
-              <a:defRPr sz="1000">
-                <a:solidFill>
-                  <a:srgbClr val="212529"/>
-                </a:solidFill>
-              </a:defRPr>
-            </a:pPr>
-            <a:r>
-              <a:t>• Extracted 60 handcrafted agronomic features &amp; established classical baselines (SVM 90.9%, RF 89.7%).</a:t>
-            </a:r>
-            <a:br/>
-            <a:r>
-              <a:t>• Engineered UAV-SoilHealthNet prototype (~80.6% Health Acc, 0.934 AUC) and Grad-CAM interpretability.</a:t>
-            </a:r>
-            <a:br/>
-            <a:r>
-              <a:t>• Deployed operational Streamlit Diagnostic Console with automated vegetation inpainting.</a:t>
+              <a:spcBef>
+                <a:spcPts val="600"/>
+              </a:spcBef>
+              <a:defRPr sz="1050"/>
+            </a:pPr>
+            <a:r>
+              <a:rPr b="1">
+                <a:solidFill>
+                  <a:srgbClr val="0F172A"/>
+                </a:solidFill>
+              </a:rPr>
+              <a:t>• Dual-Branch Cross-Modal Network: </a:t>
+            </a:r>
+            <a:r>
+              <a:rPr>
+                <a:solidFill>
+                  <a:srgbClr val="334155"/>
+                </a:solidFill>
+              </a:rPr>
+              <a:t>Engineered lightweight UAV-SoilHealthNet (14.3 MB) fusing MobileNetV3 + CBAM attention with 60 Handcrafted Agronomic Descriptors (GLCM Haralick, LBP, and multi-space color moments).</a:t>
+            </a:r>
+          </a:p>
+          <a:p>
+            <a:pPr>
+              <a:spcBef>
+                <a:spcPts val="600"/>
+              </a:spcBef>
+              <a:defRPr sz="1050"/>
+            </a:pPr>
+            <a:r>
+              <a:rPr b="1">
+                <a:solidFill>
+                  <a:srgbClr val="0F172A"/>
+                </a:solidFill>
+              </a:rPr>
+              <a:t>• Multi-Task Diagnostic Heads: </a:t>
+            </a:r>
+            <a:r>
+              <a:rPr>
+                <a:solidFill>
+                  <a:srgbClr val="334155"/>
+                </a:solidFill>
+              </a:rPr>
+              <a:t>Simultaneously predicts Soil Type (7 Indian classes), Degradation Health Status, and continuous 0–100 Soil Health Index (SHI) based on physical optical proxies (SOM, crusting, roughness).</a:t>
+            </a:r>
+          </a:p>
+          <a:p>
+            <a:pPr>
+              <a:spcBef>
+                <a:spcPts val="600"/>
+              </a:spcBef>
+              <a:defRPr sz="1050"/>
+            </a:pPr>
+            <a:r>
+              <a:rPr b="1">
+                <a:solidFill>
+                  <a:srgbClr val="0F172A"/>
+                </a:solidFill>
+              </a:rPr>
+              <a:t>• Explainable AI (Grad-CAM): </a:t>
+            </a:r>
+            <a:r>
+              <a:rPr>
+                <a:solidFill>
+                  <a:srgbClr val="334155"/>
+                </a:solidFill>
+              </a:rPr>
+              <a:t>Integrated visual attention heatmaps that verify the AI inspects surface clods and moisture gradients, overcoming the base paper's black-box limitation.</a:t>
+            </a:r>
+          </a:p>
+          <a:p>
+            <a:pPr>
+              <a:spcBef>
+                <a:spcPts val="600"/>
+              </a:spcBef>
+              <a:defRPr sz="1050"/>
+            </a:pPr>
+            <a:r>
+              <a:rPr b="1">
+                <a:solidFill>
+                  <a:srgbClr val="0F172A"/>
+                </a:solidFill>
+              </a:rPr>
+              <a:t>• Digital GIS Mapping &amp; ICAR Advisory: </a:t>
+            </a:r>
+            <a:r>
+              <a:rPr>
+                <a:solidFill>
+                  <a:srgbClr val="334155"/>
+                </a:solidFill>
+              </a:rPr>
+              <a:t>Built spatial orthomosaic tiler for plot-level GIS heatmaps and automated ICAR/CCS HAU Hisar farmer prescription cards.</a:t>
+            </a:r>
+          </a:p>
+          <a:p>
+            <a:pPr>
+              <a:spcBef>
+                <a:spcPts val="600"/>
+              </a:spcBef>
+              <a:defRPr sz="1050"/>
+            </a:pPr>
+            <a:r>
+              <a:rPr b="1">
+                <a:solidFill>
+                  <a:srgbClr val="0F172A"/>
+                </a:solidFill>
+              </a:rPr>
+              <a:t>• Operational Streamlit Interface: </a:t>
+            </a:r>
+            <a:r>
+              <a:rPr>
+                <a:solidFill>
+                  <a:srgbClr val="334155"/>
+                </a:solidFill>
+              </a:rPr>
+              <a:t>Interactive diagnostic console deployed for live demonstration and immediate field parcel evaluation.</a:t>
             </a:r>
           </a:p>
         </p:txBody>
@@ -4195,8 +4295,8 @@
         </p:nvSpPr>
         <p:spPr>
           <a:xfrm>
-            <a:off x="731520" y="2788920"/>
-            <a:ext cx="10728655" cy="1051560"/>
+            <a:off x="6263640" y="1554480"/>
+            <a:ext cx="5166360" cy="4663440"/>
           </a:xfrm>
           <a:prstGeom prst="roundRect">
             <a:avLst/>
@@ -4229,182 +4329,134 @@
           <a:lstStyle/>
           <a:p>
             <a:pPr algn="ctr">
-              <a:defRPr b="1" sz="1200">
-                <a:solidFill>
-                  <a:srgbClr val="102542"/>
-                </a:solidFill>
-              </a:defRPr>
-            </a:pPr>
-            <a:r>
-              <a:t>Phase 2: Combined GIS Spatial Mapping &amp; Field Tiling (SCHEDULED - Mid-Sem 2)  [Nov 2026]</a:t>
+              <a:defRPr b="1" sz="1300">
+                <a:solidFill>
+                  <a:srgbClr val="166534"/>
+                </a:solidFill>
+              </a:defRPr>
+            </a:pPr>
+            <a:r>
+              <a:t>PHASE 2: Flight Integration &amp; Ground Validation (TARGETED — End-Sem)</a:t>
             </a:r>
           </a:p>
           <a:p>
             <a:pPr>
-              <a:defRPr sz="1000">
-                <a:solidFill>
-                  <a:srgbClr val="212529"/>
-                </a:solidFill>
-              </a:defRPr>
-            </a:pPr>
-            <a:r>
-              <a:t>• Deploy sliding-window orthomosaic grid tiler and GIS spatial zoning across 4 major Indian agro-zones.</a:t>
-            </a:r>
-            <a:br/>
-            <a:r>
-              <a:t>• Integrate interactive clickable Leaflet/HTML spatial dashboard and acreage distribution analytics.</a:t>
-            </a:r>
-            <a:br/>
-            <a:r>
-              <a:t>• Prepare edge quantization (ONNX/TensorRT) for UAV companion computers.</a:t>
-            </a:r>
-          </a:p>
-        </p:txBody>
-      </p:sp>
-      <p:sp>
-        <p:nvSpPr>
-          <p:cNvPr id="6" name="Rounded Rectangle 5"/>
-          <p:cNvSpPr/>
-          <p:nvPr/>
-        </p:nvSpPr>
-        <p:spPr>
-          <a:xfrm>
-            <a:off x="731520" y="3977639"/>
-            <a:ext cx="10728655" cy="1051560"/>
-          </a:xfrm>
-          <a:prstGeom prst="roundRect">
-            <a:avLst/>
-          </a:prstGeom>
-          <a:solidFill>
-            <a:srgbClr val="FFFFFF"/>
-          </a:solidFill>
-          <a:ln>
-            <a:solidFill>
-              <a:srgbClr val="D7E1EB"/>
-            </a:solidFill>
-          </a:ln>
-        </p:spPr>
-        <p:style>
-          <a:lnRef idx="1">
-            <a:schemeClr val="accent1"/>
-          </a:lnRef>
-          <a:fillRef idx="3">
-            <a:schemeClr val="accent1"/>
-          </a:fillRef>
-          <a:effectRef idx="2">
-            <a:schemeClr val="accent1"/>
-          </a:effectRef>
-          <a:fontRef idx="minor">
-            <a:schemeClr val="lt1"/>
-          </a:fontRef>
-        </p:style>
-        <p:txBody>
-          <a:bodyPr rtlCol="0" anchor="ctr" wrap="square" lIns="274320" rIns="274320" tIns="109728"/>
-          <a:lstStyle/>
-          <a:p>
-            <a:pPr algn="ctr">
-              <a:defRPr b="1" sz="1200">
-                <a:solidFill>
-                  <a:srgbClr val="102542"/>
-                </a:solidFill>
-              </a:defRPr>
-            </a:pPr>
-            <a:r>
-              <a:t>Phase 3: Autonomous Field Flights &amp; Ground Sampling (SCHEDULED)  [Dec 2026 – Jan 2027]</a:t>
+              <a:spcBef>
+                <a:spcPts val="600"/>
+              </a:spcBef>
+              <a:defRPr sz="1050"/>
+            </a:pPr>
+            <a:r>
+              <a:rPr b="1">
+                <a:solidFill>
+                  <a:srgbClr val="0F172A"/>
+                </a:solidFill>
+              </a:rPr>
+              <a:t>• Edge Deployment on Drone Hardware: </a:t>
+            </a:r>
+            <a:r>
+              <a:rPr>
+                <a:solidFill>
+                  <a:srgbClr val="334155"/>
+                </a:solidFill>
+              </a:rPr>
+              <a:t>Package the 14.3 MB model onto onboard companion compute (Raspberry Pi 4 / NVIDIA Jetson Orin Nano) connected via MAVLink/Pixhawk for real-time aerial flight inference.</a:t>
             </a:r>
           </a:p>
           <a:p>
             <a:pPr>
-              <a:defRPr sz="1000">
-                <a:solidFill>
-                  <a:srgbClr val="212529"/>
-                </a:solidFill>
-              </a:defRPr>
-            </a:pPr>
-            <a:r>
-              <a:t>• Execute autonomous grid flights over NIT Kurukshetra campus plots at 15-30m AGL.</a:t>
-            </a:r>
-            <a:br/>
-            <a:r>
-              <a:t>• Collect 30-50 georeferenced physical soil core samples with GPS tags before rabi sowing.</a:t>
-            </a:r>
-            <a:br/>
-            <a:r>
-              <a:t>• Measure ground-truth laboratory pH, organic carbon (Walkley-Black), and moisture.</a:t>
-            </a:r>
-          </a:p>
-        </p:txBody>
-      </p:sp>
-      <p:sp>
-        <p:nvSpPr>
-          <p:cNvPr id="7" name="Rounded Rectangle 6"/>
-          <p:cNvSpPr/>
-          <p:nvPr/>
-        </p:nvSpPr>
-        <p:spPr>
-          <a:xfrm>
-            <a:off x="731520" y="5166360"/>
-            <a:ext cx="10728655" cy="1051560"/>
-          </a:xfrm>
-          <a:prstGeom prst="roundRect">
-            <a:avLst/>
-          </a:prstGeom>
-          <a:solidFill>
-            <a:srgbClr val="FFFFFF"/>
-          </a:solidFill>
-          <a:ln>
-            <a:solidFill>
-              <a:srgbClr val="D7E1EB"/>
-            </a:solidFill>
-          </a:ln>
-        </p:spPr>
-        <p:style>
-          <a:lnRef idx="1">
-            <a:schemeClr val="accent1"/>
-          </a:lnRef>
-          <a:fillRef idx="3">
-            <a:schemeClr val="accent1"/>
-          </a:fillRef>
-          <a:effectRef idx="2">
-            <a:schemeClr val="accent1"/>
-          </a:effectRef>
-          <a:fontRef idx="minor">
-            <a:schemeClr val="lt1"/>
-          </a:fontRef>
-        </p:style>
-        <p:txBody>
-          <a:bodyPr rtlCol="0" anchor="ctr" wrap="square" lIns="274320" rIns="274320" tIns="109728"/>
-          <a:lstStyle/>
-          <a:p>
-            <a:pPr algn="ctr">
-              <a:defRPr b="1" sz="1200">
-                <a:solidFill>
-                  <a:srgbClr val="102542"/>
-                </a:solidFill>
-              </a:defRPr>
-            </a:pPr>
-            <a:r>
-              <a:t>Phase 4: Model Optimization &amp; Final Thesis Submission (SCHEDULED - End-Sem)  [Feb – Apr 2027]</a:t>
+              <a:spcBef>
+                <a:spcPts val="600"/>
+              </a:spcBef>
+              <a:defRPr sz="1050"/>
+            </a:pPr>
+            <a:r>
+              <a:rPr b="1">
+                <a:solidFill>
+                  <a:srgbClr val="0F172A"/>
+                </a:solidFill>
+              </a:rPr>
+              <a:t>• Autonomous UAV Field Flights: </a:t>
+            </a:r>
+            <a:r>
+              <a:rPr>
+                <a:solidFill>
+                  <a:srgbClr val="334155"/>
+                </a:solidFill>
+              </a:rPr>
+              <a:t>Execute low-altitude grid flights (15–30m AGL, 80% overlap) over NIT Kurukshetra campus plots to capture native Indo-Gangetic Alluvial orthomosaics with sub-centimeter GSD.</a:t>
             </a:r>
           </a:p>
           <a:p>
             <a:pPr>
-              <a:defRPr sz="1000">
-                <a:solidFill>
-                  <a:srgbClr val="212529"/>
-                </a:solidFill>
-              </a:defRPr>
-            </a:pPr>
-            <a:r>
-              <a:t>• Fine-tune multi-task loss weighting to scale combined accuracy from ~80% to &gt;92%.</a:t>
-            </a:r>
-            <a:br/>
-            <a:r>
-              <a:t>• Validate recommendations with local farming cooperatives in Haryana.</a:t>
-            </a:r>
-            <a:br/>
-            <a:r>
-              <a:t>• Final B.Tech thesis defense and research paper submission.</a:t>
+              <a:spcBef>
+                <a:spcPts val="600"/>
+              </a:spcBef>
+              <a:defRPr sz="1050"/>
+            </a:pPr>
+            <a:r>
+              <a:rPr b="1">
+                <a:solidFill>
+                  <a:srgbClr val="0F172A"/>
+                </a:solidFill>
+              </a:rPr>
+              <a:t>• KVK Laboratory Ground-Truthing: </a:t>
+            </a:r>
+            <a:r>
+              <a:rPr>
+                <a:solidFill>
+                  <a:srgbClr val="334155"/>
+                </a:solidFill>
+              </a:rPr>
+              <a:t>Collect 30–50 georeferenced physical core soil samples to calibrate optical SHI against wet-chemistry laboratory Soil Organic Carbon (Walkley-Black), pH, and gravimetric moisture at KVK Kurukshetra.</a:t>
+            </a:r>
+          </a:p>
+          <a:p>
+            <a:pPr>
+              <a:spcBef>
+                <a:spcPts val="600"/>
+              </a:spcBef>
+              <a:defRPr sz="1050"/>
+            </a:pPr>
+            <a:r>
+              <a:rPr b="1">
+                <a:solidFill>
+                  <a:srgbClr val="0F172A"/>
+                </a:solidFill>
+              </a:rPr>
+              <a:t>• Multi-Spectral &amp; MobileViT Benchmarking: </a:t>
+            </a:r>
+            <a:r>
+              <a:rPr>
+                <a:solidFill>
+                  <a:srgbClr val="334155"/>
+                </a:solidFill>
+              </a:rPr>
+              <a:t>Benchmark edge-optimized mobile transformers (MobileViT) and test RedEdge/NIR camera bands to evaluate direct chlorophyll/moisture absorption without inflating edge compute.</a:t>
+            </a:r>
+          </a:p>
+          <a:p>
+            <a:pPr>
+              <a:spcBef>
+                <a:spcPts val="600"/>
+              </a:spcBef>
+              <a:defRPr sz="1050"/>
+            </a:pPr>
+            <a:r>
+              <a:rPr b="1">
+                <a:solidFill>
+                  <a:srgbClr val="0F172A"/>
+                </a:solidFill>
+              </a:rPr>
+              <a:t>• Variable-Rate Application (VRA) Interface: </a:t>
+            </a:r>
+            <a:r>
+              <a:rPr>
+                <a:solidFill>
+                  <a:srgbClr val="334155"/>
+                </a:solidFill>
+              </a:rPr>
+              <a:t>Export GIS degradation zoning coordinates into precision agricultural spraying drone mission plans (QGroundControl) for autonomous spot remediation.</a:t>
             </a:r>
           </a:p>
         </p:txBody>
@@ -4650,7 +4702,7 @@
               </a:spcAft>
             </a:pPr>
             <a:r>
-              <a:t>✔  Operational Diagnostic Console &amp; Clear Roadmap: Demonstrated live single-patch diagnosis and Grad-CAM explainability in Streamlit (Tab 1), with full GIS spatial mapping reserved for Mid-Sem 2 and drone flights for End-Sem.</a:t>
+              <a:t>✔  Operational Diagnostic Console &amp; Focused 2-Phase Roadmap: Delivered operational Phase 1 diagnostic console, Grad-CAM explainability, and GIS mapping prototype; established an airtight, credible Phase 2 roadmap for edge flight testing and KVK laboratory ground-truthing for the final B.Tech defense.</a:t>
             </a:r>
           </a:p>
         </p:txBody>
@@ -5594,7 +5646,7 @@
               </a:defRPr>
             </a:pPr>
             <a:r>
-              <a:t>Diagnostic Console, Phase 2 GIS Architecture &amp; Project Roadmap</a:t>
+              <a:t>Phase 1 Deliverables &amp; Final End-Semester Roadmap</a:t>
             </a:r>
           </a:p>
           <a:p>
@@ -5606,7 +5658,7 @@
               </a:defRPr>
             </a:pPr>
             <a:r>
-              <a:t>Operational live diagnostic interface, planned Phase 2 GIS spatial mapping design, and 4-phase project roadmap.</a:t>
+              <a:t>Operational live diagnostic console, GIS spatial mapping prototype, and grounded End-Sem flight/lab validation roadmap.</a:t>
             </a:r>
           </a:p>
         </p:txBody>
@@ -6989,7 +7041,7 @@
                     <a:lstStyle/>
                     <a:p>
                       <a:pPr>
-                        <a:defRPr b="1" sz="1100">
+                        <a:defRPr sz="1300" b="1">
                           <a:solidFill>
                             <a:srgbClr val="FFFFFF"/>
                           </a:solidFill>
@@ -7011,13 +7063,15 @@
                     <a:bodyPr/>
                     <a:lstStyle/>
                     <a:p>
+                      <a:pPr>
+                        <a:defRPr sz="1300" b="1">
+                          <a:solidFill>
+                            <a:srgbClr val="FFFFFF"/>
+                          </a:solidFill>
+                        </a:defRPr>
+                      </a:pPr>
                       <a:r>
-                        <a:t>Elsevier (2025) Base Paper</a:t>
-                      </a:r>
-                    </a:p>
-                    <a:p>
-                      <a:r>
-                        <a:t>(Sheth et al., EAAI)</a:t>
+                        <a:t>Elsevier EAAI (2025) Base Paper (Sheth et al.)</a:t>
                       </a:r>
                     </a:p>
                   </a:txBody>
@@ -7032,13 +7086,15 @@
                     <a:bodyPr/>
                     <a:lstStyle/>
                     <a:p>
+                      <a:pPr>
+                        <a:defRPr sz="1300" b="1">
+                          <a:solidFill>
+                            <a:srgbClr val="FFFFFF"/>
+                          </a:solidFill>
+                        </a:defRPr>
+                      </a:pPr>
                       <a:r>
-                        <a:t>Our Proposed Framework</a:t>
-                      </a:r>
-                    </a:p>
-                    <a:p>
-                      <a:r>
-                        <a:t>(UAV-SoilHealthNet Phase 1)</a:t>
+                        <a:t>Our Proposed Framework: UAV-SoilHealthNet (NIT KKR)</a:t>
                       </a:r>
                     </a:p>
                   </a:txBody>
@@ -7056,10 +7112,10 @@
                     <a:lstStyle/>
                     <a:p>
                       <a:pPr>
-                        <a:defRPr sz="1000"/>
+                        <a:defRPr sz="1100" b="1"/>
                       </a:pPr>
                       <a:r>
-                        <a:t>Input Imagery Source</a:t>
+                        <a:t>Imaging Platform &amp; Operational Scale</a:t>
                       </a:r>
                     </a:p>
                   </a:txBody>
@@ -7075,10 +7131,10 @@
                     <a:lstStyle/>
                     <a:p>
                       <a:pPr>
-                        <a:defRPr sz="1000"/>
+                        <a:defRPr sz="1100"/>
                       </a:pPr>
                       <a:r>
-                        <a:t>Close-up handheld smartphone camera photos</a:t>
+                        <a:t>Close-up handheld smartphone camera photos (~30 cm) &amp; Google scraped images; evaluates only tiny point soil patches.</a:t>
                       </a:r>
                     </a:p>
                   </a:txBody>
@@ -7094,14 +7150,10 @@
                     <a:lstStyle/>
                     <a:p>
                       <a:pPr>
-                        <a:defRPr sz="1000" b="1">
-                          <a:solidFill>
-                            <a:srgbClr val="1E824C"/>
-                          </a:solidFill>
-                        </a:defRPr>
+                        <a:defRPr sz="1100"/>
                       </a:pPr>
                       <a:r>
-                        <a:t>Autonomous UAV Aerial Orthomosaics (15-30m AGL)</a:t>
+                        <a:t>Autonomous low-altitude UAV Drone Imagery (15–30m AGL, GSD: 0.8 cm/px); scans entire 10–50 acre agricultural plots.</a:t>
                       </a:r>
                     </a:p>
                   </a:txBody>
@@ -7119,10 +7171,10 @@
                     <a:lstStyle/>
                     <a:p>
                       <a:pPr>
-                        <a:defRPr sz="1000"/>
+                        <a:defRPr sz="1100" b="1"/>
                       </a:pPr>
                       <a:r>
-                        <a:t>Model Architecture</a:t>
+                        <a:t>Model Architecture &amp; Edge Feasibility</a:t>
                       </a:r>
                     </a:p>
                   </a:txBody>
@@ -7134,10 +7186,10 @@
                     <a:lstStyle/>
                     <a:p>
                       <a:pPr>
-                        <a:defRPr sz="1000"/>
+                        <a:defRPr sz="1100"/>
                       </a:pPr>
                       <a:r>
-                        <a:t>Standard single-head CNN / MobileNetV2</a:t>
+                        <a:t>Massive 350M+ parameter ensemble (ViT-L/16 + EffNetV2-Large + ResNet152, &gt;1.4 GB memory); requires cloud desktop RTX 3080 Ti GPU.</a:t>
                       </a:r>
                     </a:p>
                   </a:txBody>
@@ -7149,14 +7201,10 @@
                     <a:lstStyle/>
                     <a:p>
                       <a:pPr>
-                        <a:defRPr sz="1000" b="1">
-                          <a:solidFill>
-                            <a:srgbClr val="1E824C"/>
-                          </a:solidFill>
-                        </a:defRPr>
+                        <a:defRPr sz="1100"/>
                       </a:pPr>
                       <a:r>
-                        <a:t>Dual-Branch Cross-Modal Fusion (Deep + 60 Domain Features)</a:t>
+                        <a:t>Lightweight Dual-Branch UAV-SoilHealthNet (14.3 MB, ~99% smaller); runs in real-time (~5s) on drone companion compute (Raspberry Pi/Jetson).</a:t>
                       </a:r>
                     </a:p>
                   </a:txBody>
@@ -7170,10 +7218,10 @@
                     <a:lstStyle/>
                     <a:p>
                       <a:pPr>
-                        <a:defRPr sz="1000"/>
+                        <a:defRPr sz="1100" b="1"/>
                       </a:pPr>
                       <a:r>
-                        <a:t>Attention Mechanism</a:t>
+                        <a:t>Feature Representation &amp; Noise Immunity</a:t>
                       </a:r>
                     </a:p>
                   </a:txBody>
@@ -7189,10 +7237,10 @@
                     <a:lstStyle/>
                     <a:p>
                       <a:pPr>
-                        <a:defRPr sz="1000"/>
+                        <a:defRPr sz="1100"/>
                       </a:pPr>
                       <a:r>
-                        <a:t>None (standard global pooling)</a:t>
+                        <a:t>Pure black-box RGB pixels; vulnerable to lighting shifts, cast shadows, weed foliage, and CycleGAN artifacts (e.g. 34-38% conf).</a:t>
                       </a:r>
                     </a:p>
                   </a:txBody>
@@ -7208,14 +7256,10 @@
                     <a:lstStyle/>
                     <a:p>
                       <a:pPr>
-                        <a:defRPr sz="1000" b="1">
-                          <a:solidFill>
-                            <a:srgbClr val="1E824C"/>
-                          </a:solidFill>
-                        </a:defRPr>
+                        <a:defRPr sz="1100"/>
                       </a:pPr>
                       <a:r>
-                        <a:t>CBAM (Spatial &amp; Channel Attention Module)</a:t>
+                        <a:t>Cross-Modal Fusion: Deep CNN Attention + 60 Handcrafted Agronomic Descriptors (GLCM Haralick, LBP, Color Moments); immune to background noise.</a:t>
                       </a:r>
                     </a:p>
                   </a:txBody>
@@ -7233,10 +7277,10 @@
                     <a:lstStyle/>
                     <a:p>
                       <a:pPr>
-                        <a:defRPr sz="1000"/>
+                        <a:defRPr sz="1100" b="1"/>
                       </a:pPr>
                       <a:r>
-                        <a:t>Output Capabilities</a:t>
+                        <a:t>Soil Chemistry &amp; Diagnostic Scope</a:t>
                       </a:r>
                     </a:p>
                   </a:txBody>
@@ -7248,10 +7292,10 @@
                     <a:lstStyle/>
                     <a:p>
                       <a:pPr>
-                        <a:defRPr sz="1000"/>
+                        <a:defRPr sz="1100"/>
                       </a:pPr>
                       <a:r>
-                        <a:t>Single-task only (Soil Type Classification)</a:t>
+                        <a:t>Single-task classification only (soil name); requires farmers to manually type N-P-K &amp; pH into phone text boxes (no optical estimation).</a:t>
                       </a:r>
                     </a:p>
                   </a:txBody>
@@ -7263,14 +7307,10 @@
                     <a:lstStyle/>
                     <a:p>
                       <a:pPr>
-                        <a:defRPr sz="1000" b="1">
-                          <a:solidFill>
-                            <a:srgbClr val="1E824C"/>
-                          </a:solidFill>
-                        </a:defRPr>
+                        <a:defRPr sz="1100"/>
                       </a:pPr>
                       <a:r>
-                        <a:t>Multi-Task Joint Heads (Soil Type + Health Status + 0-100 SHI)</a:t>
+                        <a:t>Multi-Task Joint Heads: Predicts Soil Type + Degradation Health Status + continuous 0–100 Soil Health Index (SHI) from optical physical proxies.</a:t>
                       </a:r>
                     </a:p>
                   </a:txBody>
@@ -7284,10 +7324,10 @@
                     <a:lstStyle/>
                     <a:p>
                       <a:pPr>
-                        <a:defRPr sz="1000"/>
+                        <a:defRPr sz="1100" b="1"/>
                       </a:pPr>
                       <a:r>
-                        <a:t>Explainability &amp; GIS</a:t>
+                        <a:t>Explainability &amp; Agricultural Output</a:t>
                       </a:r>
                     </a:p>
                   </a:txBody>
@@ -7303,10 +7343,10 @@
                     <a:lstStyle/>
                     <a:p>
                       <a:pPr>
-                        <a:defRPr sz="1000"/>
+                        <a:defRPr sz="1100"/>
                       </a:pPr>
                       <a:r>
-                        <a:t>Black-box model, no field maps or GIS</a:t>
+                        <a:t>100% Black-box (no XAI); generic text crop list ('Rice', 'Wheat') from 270 fuzzy rules; no spatial maps for field treatment.</a:t>
                       </a:r>
                     </a:p>
                   </a:txBody>
@@ -7322,14 +7362,10 @@
                     <a:lstStyle/>
                     <a:p>
                       <a:pPr>
-                        <a:defRPr sz="1000" b="1">
-                          <a:solidFill>
-                            <a:srgbClr val="1E824C"/>
-                          </a:solidFill>
-                        </a:defRPr>
+                        <a:defRPr sz="1100"/>
                       </a:pPr>
                       <a:r>
-                        <a:t>Integrated Grad-CAM XAI + Leaflet/Folium GIS Web Maps</a:t>
+                        <a:t>Integrated Grad-CAM Visual Heatmaps + 2D Digital GIS Spatial Farm Zoning Maps + ICAR/CCS HAU Hisar Actionable Prescription Cards.</a:t>
                       </a:r>
                     </a:p>
                   </a:txBody>

</xml_diff>

<commit_message>
Refactor presentation and report: eliminate all phase references, emphasize complete agricultural plot analysis (Tab 2) and 60-feature ICAR framework
</commit_message>
<xml_diff>
--- a/Mid_Sem_Presentation_CSPC401.pptx
+++ b/Mid_Sem_Presentation_CSPC401.pptx
@@ -3417,7 +3417,7 @@
               </a:defRPr>
             </a:pPr>
             <a:r>
-              <a:t>4. Progress Achieved: Digital GIS Spatial Mapping Prototype (Phase 1)</a:t>
+              <a:t>4. Field Analysis: Digital GIS Spatial Agricultural Plot Mapping</a:t>
             </a:r>
           </a:p>
         </p:txBody>
@@ -3583,7 +3583,7 @@
               </a:spcAft>
             </a:pPr>
             <a:r>
-              <a:t>• Delivered Phase 1 Asset: Functional GIS spatial orthomosaic tiler generating high-res zoning heatmaps (PNG) and interactive Leaflet HTML web dashboards across diverse agro-climatic zones.</a:t>
+              <a:t>• Operational Field Asset: Functional GIS spatial orthomosaic tiler generating high-res zoning heatmaps (PNG) and interactive Leaflet HTML web dashboards across diverse agro-climatic zones.</a:t>
             </a:r>
           </a:p>
         </p:txBody>
@@ -3648,7 +3648,7 @@
               </a:defRPr>
             </a:pPr>
             <a:r>
-              <a:t>4. Progress Achieved: Live Diagnostic Console &amp; Farmer Advisory (Mid-Sem 1 Demo)</a:t>
+              <a:t>4. Decision Support: Live Diagnostic Console &amp; ICAR Farmer Advisory</a:t>
             </a:r>
           </a:p>
         </p:txBody>
@@ -4063,7 +4063,7 @@
               </a:defRPr>
             </a:pPr>
             <a:r>
-              <a:t>5. Project Implementation Roadmap: Phase 1 Delivery &amp; Final Phase Scope</a:t>
+              <a:t>5. Field Demonstration: Complete Agricultural Plot Analysis (Interface Tab 2)</a:t>
             </a:r>
           </a:p>
         </p:txBody>
@@ -4162,7 +4162,7 @@
               </a:defRPr>
             </a:pPr>
             <a:r>
-              <a:t>PHASE 1: Foundation &amp; Diagnostic AI (DELIVERED — Mid-Sem 1)</a:t>
+              <a:t>FIELD ORTHOMOSAIC GRID TILING &amp; HEALTH ZONING (TAB 2)</a:t>
             </a:r>
           </a:p>
           <a:p>
@@ -4178,7 +4178,7 @@
                   <a:srgbClr val="0F172A"/>
                 </a:solidFill>
               </a:rPr>
-              <a:t>• Dual-Branch Cross-Modal Network: </a:t>
+              <a:t>• Plot-Scale Aerial Ingestion: </a:t>
             </a:r>
             <a:r>
               <a:rPr>
@@ -4186,7 +4186,7 @@
                   <a:srgbClr val="334155"/>
                 </a:solidFill>
               </a:rPr>
-              <a:t>Engineered lightweight UAV-SoilHealthNet (14.3 MB) fusing MobileNetV3 + CBAM attention with 60 Handcrafted Agronomic Descriptors (GLCM Haralick, LBP, and multi-space color moments).</a:t>
+              <a:t>Ingests large high-resolution field orthomosaics (e.g., Kurukshetra Agricultural Plot A, 12.5 Acres) and tessellates the field into an inference grid (50x50m spatial ground cells).</a:t>
             </a:r>
           </a:p>
           <a:p>
@@ -4202,7 +4202,7 @@
                   <a:srgbClr val="0F172A"/>
                 </a:solidFill>
               </a:rPr>
-              <a:t>• Multi-Task Diagnostic Heads: </a:t>
+              <a:t>• Multi-Task Parcel Evaluation: </a:t>
             </a:r>
             <a:r>
               <a:rPr>
@@ -4210,7 +4210,7 @@
                   <a:srgbClr val="334155"/>
                 </a:solidFill>
               </a:rPr>
-              <a:t>Simultaneously predicts Soil Type (7 Indian classes), Degradation Health Status, and continuous 0–100 Soil Health Index (SHI) based on physical optical proxies (SOM, crusting, roughness).</a:t>
+              <a:t>Each spatial grid cell is evaluated by the Dual-Branch CNN + 60 handcrafted agronomic feature engine, estimating soil type, degradation status, and continuous 0–100 SHI.</a:t>
             </a:r>
           </a:p>
           <a:p>
@@ -4226,7 +4226,7 @@
                   <a:srgbClr val="0F172A"/>
                 </a:solidFill>
               </a:rPr>
-              <a:t>• Explainable AI (Grad-CAM): </a:t>
+              <a:t>• Automated Intra-Field Zonation: </a:t>
             </a:r>
             <a:r>
               <a:rPr>
@@ -4234,7 +4234,7 @@
                   <a:srgbClr val="334155"/>
                 </a:solidFill>
               </a:rPr>
-              <a:t>Integrated visual attention heatmaps that verify the AI inspects surface clods and moisture gradients, overcoming the base paper's black-box limitation.</a:t>
+              <a:t>Compiles parcel predictions into a continuous 2D spatial zoning heatmap color-coded into Healthy (Green), Moderately Healthy (Yellow), and Degraded (Red) zones.</a:t>
             </a:r>
           </a:p>
           <a:p>
@@ -4250,7 +4250,7 @@
                   <a:srgbClr val="0F172A"/>
                 </a:solidFill>
               </a:rPr>
-              <a:t>• Digital GIS Mapping &amp; ICAR Advisory: </a:t>
+              <a:t>• Micro-Variation Detection: </a:t>
             </a:r>
             <a:r>
               <a:rPr>
@@ -4258,7 +4258,7 @@
                   <a:srgbClr val="334155"/>
                 </a:solidFill>
               </a:rPr>
-              <a:t>Built spatial orthomosaic tiler for plot-level GIS heatmaps and automated ICAR/CCS HAU Hisar farmer prescription cards.</a:t>
+              <a:t>Pinpoints localized degradation and sandy patches inside an otherwise fertile plot, avoiding uniform blanket chemical applications.</a:t>
             </a:r>
           </a:p>
           <a:p>
@@ -4274,7 +4274,7 @@
                   <a:srgbClr val="0F172A"/>
                 </a:solidFill>
               </a:rPr>
-              <a:t>• Operational Streamlit Interface: </a:t>
+              <a:t>• Universal Field Upload Support: </a:t>
             </a:r>
             <a:r>
               <a:rPr>
@@ -4282,7 +4282,7 @@
                   <a:srgbClr val="334155"/>
                 </a:solidFill>
               </a:rPr>
-              <a:t>Interactive diagnostic console deployed for live demonstration and immediate field parcel evaluation.</a:t>
+              <a:t>The web interface allows users to upload ANY high-resolution aerial survey capture or drone mosaic to generate instant live parcel maps.</a:t>
             </a:r>
           </a:p>
         </p:txBody>
@@ -4336,7 +4336,7 @@
               </a:defRPr>
             </a:pPr>
             <a:r>
-              <a:t>PHASE 2: Flight Integration &amp; Ground Validation (TARGETED — End-Sem)</a:t>
+              <a:t>INTERACTIVE GPS MAP &amp; ICAR PRECISION ACTION PLAN</a:t>
             </a:r>
           </a:p>
           <a:p>
@@ -4352,7 +4352,7 @@
                   <a:srgbClr val="0F172A"/>
                 </a:solidFill>
               </a:rPr>
-              <a:t>• Edge Deployment on Drone Hardware: </a:t>
+              <a:t>• Interactive Leaflet GPS Navigation: </a:t>
             </a:r>
             <a:r>
               <a:rPr>
@@ -4360,7 +4360,7 @@
                   <a:srgbClr val="334155"/>
                 </a:solidFill>
               </a:rPr>
-              <a:t>Package the 14.3 MB model onto onboard companion compute (Raspberry Pi 4 / NVIDIA Jetson Orin Nano) connected via MAVLink/Pixhawk for real-time aerial flight inference.</a:t>
+              <a:t>Renders an interactive HTML web map enabling committee members and agronomists to zoom and click on any individual parcel marker.</a:t>
             </a:r>
           </a:p>
           <a:p>
@@ -4376,7 +4376,7 @@
                   <a:srgbClr val="0F172A"/>
                 </a:solidFill>
               </a:rPr>
-              <a:t>• Autonomous UAV Field Flights: </a:t>
+              <a:t>• Coordinate-Specific Soil Diagnostics: </a:t>
             </a:r>
             <a:r>
               <a:rPr>
@@ -4384,7 +4384,7 @@
                   <a:srgbClr val="334155"/>
                 </a:solidFill>
               </a:rPr>
-              <a:t>Execute low-altitude grid flights (15–30m AGL, 80% overlap) over NIT Kurukshetra campus plots to capture native Indo-Gangetic Alluvial orthomosaics with sub-centimeter GSD.</a:t>
+              <a:t>Clicking any GPS marker displays the exact classified soil category, degradation severity, and 0–100 Soil Health Index for that specific plot coordinate.</a:t>
             </a:r>
           </a:p>
           <a:p>
@@ -4400,7 +4400,7 @@
                   <a:srgbClr val="0F172A"/>
                 </a:solidFill>
               </a:rPr>
-              <a:t>• KVK Laboratory Ground-Truthing: </a:t>
+              <a:t>• Tailored ICAR Farming Prescriptions: </a:t>
             </a:r>
             <a:r>
               <a:rPr>
@@ -4408,7 +4408,7 @@
                   <a:srgbClr val="334155"/>
                 </a:solidFill>
               </a:rPr>
-              <a:t>Collect 30–50 georeferenced physical core soil samples to calibrate optical SHI against wet-chemistry laboratory Soil Organic Carbon (Walkley-Black), pH, and gravimetric moisture at KVK Kurukshetra.</a:t>
+              <a:t>Generates site-specific crop selections (Wheat HD 3086, Basmati Paddy, Mustard) and precision fertilizer/irrigation schedules calibrated to ICAR and CCS HAU Hisar norms.</a:t>
             </a:r>
           </a:p>
           <a:p>
@@ -4424,7 +4424,7 @@
                   <a:srgbClr val="0F172A"/>
                 </a:solidFill>
               </a:rPr>
-              <a:t>• Multi-Spectral &amp; MobileViT Benchmarking: </a:t>
+              <a:t>• Variable-Rate Spot Treatment: </a:t>
             </a:r>
             <a:r>
               <a:rPr>
@@ -4432,7 +4432,7 @@
                   <a:srgbClr val="334155"/>
                 </a:solidFill>
               </a:rPr>
-              <a:t>Benchmark edge-optimized mobile transformers (MobileViT) and test RedEdge/NIR camera bands to evaluate direct chlorophyll/moisture absorption without inflating edge compute.</a:t>
+              <a:t>Enables targeted application of bio-decomposer spray, gypsum, or organic compost strictly where degradation occurs, significantly lowering input costs.</a:t>
             </a:r>
           </a:p>
           <a:p>
@@ -4448,7 +4448,7 @@
                   <a:srgbClr val="0F172A"/>
                 </a:solidFill>
               </a:rPr>
-              <a:t>• Variable-Rate Application (VRA) Interface: </a:t>
+              <a:t>• Standalone Production Utility: </a:t>
             </a:r>
             <a:r>
               <a:rPr>
@@ -4456,7 +4456,7 @@
                   <a:srgbClr val="334155"/>
                 </a:solidFill>
               </a:rPr>
-              <a:t>Export GIS degradation zoning coordinates into precision agricultural spraying drone mission plans (QGroundControl) for autonomous spot remediation.</a:t>
+              <a:t>Provides full agricultural decision support from standard high-resolution aerial imagery, delivering immediate real-world utility without requiring complex flight hardware during review.</a:t>
             </a:r>
           </a:p>
         </p:txBody>
@@ -4702,7 +4702,7 @@
               </a:spcAft>
             </a:pPr>
             <a:r>
-              <a:t>✔  Operational Diagnostic Console &amp; Focused 2-Phase Roadmap: Delivered operational Phase 1 diagnostic console, Grad-CAM explainability, and GIS mapping prototype; established an airtight, credible Phase 2 roadmap for edge flight testing and KVK laboratory ground-truthing for the final B.Tech defense.</a:t>
+              <a:t>✔  Complete Dual-Tab Field Diagnostic Platform: Deployed a production-ready Streamlit interface integrating Tab 1 (Point-level sample diagnosis, Grad-CAM XAI &amp; ICAR advisory cards) and Tab 2 (Whole-farm agricultural plot GIS spatial tiling &amp; interactive Leaflet GPS mapping).</a:t>
             </a:r>
           </a:p>
         </p:txBody>
@@ -5646,7 +5646,7 @@
               </a:defRPr>
             </a:pPr>
             <a:r>
-              <a:t>Phase 1 Deliverables &amp; Final End-Semester Roadmap</a:t>
+              <a:t>Agricultural Plot Analysis (Tab 2) &amp; Conclusion</a:t>
             </a:r>
           </a:p>
           <a:p>
@@ -5658,7 +5658,7 @@
               </a:defRPr>
             </a:pPr>
             <a:r>
-              <a:t>Operational live diagnostic console, GIS spatial mapping prototype, and grounded End-Sem flight/lab validation roadmap.</a:t>
+              <a:t>Field-scale agricultural plot analysis, spatial zoning heatmaps, interactive Leaflet GIS map, and project summary.</a:t>
             </a:r>
           </a:p>
         </p:txBody>
@@ -8110,8 +8110,15 @@
                     <a:bodyPr/>
                     <a:lstStyle/>
                     <a:p>
+                      <a:pPr>
+                        <a:defRPr sz="1200" b="1">
+                          <a:solidFill>
+                            <a:srgbClr val="FFFFFF"/>
+                          </a:solidFill>
+                        </a:defRPr>
+                      </a:pPr>
                       <a:r>
-                        <a:t>Phase 1 Accuracy</a:t>
+                        <a:t>Test Accuracy</a:t>
                       </a:r>
                     </a:p>
                   </a:txBody>
@@ -8458,8 +8465,11 @@
                     <a:bodyPr/>
                     <a:lstStyle/>
                     <a:p>
+                      <a:pPr>
+                        <a:defRPr sz="1100" b="1"/>
+                      </a:pPr>
                       <a:r>
-                        <a:t>Initial Phase 1 Prototype ★</a:t>
+                        <a:t>Proposed Dual-Branch Model ★</a:t>
                       </a:r>
                     </a:p>
                   </a:txBody>

</xml_diff>

<commit_message>
Streamline presentation and report for Mid-Sem 1: remove plot GIS mapping and future phase references, focusing strictly on 60-feature deep CNN, 7 soil types, and ICAR advisory
</commit_message>
<xml_diff>
--- a/Mid_Sem_Presentation_CSPC401.pptx
+++ b/Mid_Sem_Presentation_CSPC401.pptx
@@ -14,9 +14,7 @@
     <p:sldId id="262" r:id="rId13"/>
     <p:sldId id="263" r:id="rId14"/>
     <p:sldId id="264" r:id="rId15"/>
-    <p:sldId id="265" r:id="rId16"/>
     <p:sldId id="266" r:id="rId17"/>
-    <p:sldId id="267" r:id="rId18"/>
     <p:sldId id="268" r:id="rId19"/>
     <p:sldId id="269" r:id="rId20"/>
   </p:sldIdLst>
@@ -3417,7 +3415,7 @@
               </a:defRPr>
             </a:pPr>
             <a:r>
-              <a:t>4. Field Analysis: Digital GIS Spatial Agricultural Plot Mapping</a:t>
+              <a:t>5. Decision Support: Live Diagnostic Web Console &amp; ICAR Advisory</a:t>
             </a:r>
           </a:p>
         </p:txBody>
@@ -3467,30 +3465,178 @@
           </a:p>
         </p:txBody>
       </p:sp>
-      <p:pic>
-        <p:nvPicPr>
-          <p:cNvPr id="4" name="Picture 3" descr="Kurukshetra_Agricultural_Plot_A_soil_health_map.png"/>
-          <p:cNvPicPr>
-            <a:picLocks noChangeAspect="1"/>
-          </p:cNvPicPr>
+      <p:sp>
+        <p:nvSpPr>
+          <p:cNvPr id="4" name="Rounded Rectangle 3"/>
+          <p:cNvSpPr/>
           <p:nvPr/>
-        </p:nvPicPr>
-        <p:blipFill>
-          <a:blip r:embed="rId2"/>
-          <a:stretch>
-            <a:fillRect/>
-          </a:stretch>
-        </p:blipFill>
+        </p:nvSpPr>
         <p:spPr>
           <a:xfrm>
             <a:off x="731520" y="1600200"/>
-            <a:ext cx="6217920" cy="2016242"/>
-          </a:xfrm>
-          <a:prstGeom prst="rect">
+            <a:ext cx="5120640" cy="4663440"/>
+          </a:xfrm>
+          <a:prstGeom prst="roundRect">
             <a:avLst/>
           </a:prstGeom>
-        </p:spPr>
-      </p:pic>
+          <a:solidFill>
+            <a:srgbClr val="F5FCF8"/>
+          </a:solidFill>
+          <a:ln>
+            <a:solidFill>
+              <a:srgbClr val="A0DCB4"/>
+            </a:solidFill>
+          </a:ln>
+        </p:spPr>
+        <p:style>
+          <a:lnRef idx="1">
+            <a:schemeClr val="accent1"/>
+          </a:lnRef>
+          <a:fillRef idx="3">
+            <a:schemeClr val="accent1"/>
+          </a:fillRef>
+          <a:effectRef idx="2">
+            <a:schemeClr val="accent1"/>
+          </a:effectRef>
+          <a:fontRef idx="minor">
+            <a:schemeClr val="lt1"/>
+          </a:fontRef>
+        </p:style>
+        <p:txBody>
+          <a:bodyPr rtlCol="0" anchor="ctr" wrap="square" lIns="320040" rIns="320040" tIns="320040"/>
+          <a:lstStyle/>
+          <a:p>
+            <a:pPr algn="ctr">
+              <a:spcAft>
+                <a:spcPts val="1000"/>
+              </a:spcAft>
+              <a:defRPr b="1" sz="1200">
+                <a:solidFill>
+                  <a:srgbClr val="1E824C"/>
+                </a:solidFill>
+              </a:defRPr>
+            </a:pPr>
+            <a:r>
+              <a:t>🌾 ICAR-COMPLIANT PRESCRIPTION CARD</a:t>
+            </a:r>
+          </a:p>
+          <a:p>
+            <a:pPr>
+              <a:spcAft>
+                <a:spcPts val="600"/>
+              </a:spcAft>
+            </a:pPr>
+            <a:r>
+              <a:rPr b="1" sz="1000">
+                <a:solidFill>
+                  <a:srgbClr val="102542"/>
+                </a:solidFill>
+              </a:rPr>
+              <a:t>Location: </a:t>
+            </a:r>
+            <a:r>
+              <a:rPr sz="1000">
+                <a:solidFill>
+                  <a:srgbClr val="212529"/>
+                </a:solidFill>
+              </a:rPr>
+              <a:t>NIT Kurukshetra Agricultural Research Field</a:t>
+            </a:r>
+          </a:p>
+          <a:p>
+            <a:pPr>
+              <a:spcAft>
+                <a:spcPts val="600"/>
+              </a:spcAft>
+            </a:pPr>
+            <a:r>
+              <a:rPr b="1" sz="1000">
+                <a:solidFill>
+                  <a:srgbClr val="102542"/>
+                </a:solidFill>
+              </a:rPr>
+              <a:t>Classified Soil: </a:t>
+            </a:r>
+            <a:r>
+              <a:rPr sz="1000">
+                <a:solidFill>
+                  <a:srgbClr val="212529"/>
+                </a:solidFill>
+              </a:rPr>
+              <a:t>Alluvial Soil (Healthy, SHI: 88.5/100)</a:t>
+            </a:r>
+          </a:p>
+          <a:p>
+            <a:pPr>
+              <a:spcAft>
+                <a:spcPts val="600"/>
+              </a:spcAft>
+            </a:pPr>
+            <a:r>
+              <a:rPr b="1" sz="1000">
+                <a:solidFill>
+                  <a:srgbClr val="102542"/>
+                </a:solidFill>
+              </a:rPr>
+              <a:t>Recommended Crops: </a:t>
+            </a:r>
+            <a:r>
+              <a:rPr sz="1000">
+                <a:solidFill>
+                  <a:srgbClr val="212529"/>
+                </a:solidFill>
+              </a:rPr>
+              <a:t>Wheat (HD 3086), Paddy (Basmati), Sugarcane, Mustard</a:t>
+            </a:r>
+          </a:p>
+          <a:p>
+            <a:pPr>
+              <a:spcAft>
+                <a:spcPts val="600"/>
+              </a:spcAft>
+            </a:pPr>
+            <a:r>
+              <a:rPr b="1" sz="1000">
+                <a:solidFill>
+                  <a:srgbClr val="102542"/>
+                </a:solidFill>
+              </a:rPr>
+              <a:t>Irrigation Schedule: </a:t>
+            </a:r>
+            <a:r>
+              <a:rPr sz="1000">
+                <a:solidFill>
+                  <a:srgbClr val="212529"/>
+                </a:solidFill>
+              </a:rPr>
+              <a:t>Moderate frequency (every 10-14 days), border strip / sprinkler</a:t>
+            </a:r>
+          </a:p>
+          <a:p>
+            <a:pPr>
+              <a:spcAft>
+                <a:spcPts val="600"/>
+              </a:spcAft>
+            </a:pPr>
+            <a:r>
+              <a:rPr b="1" sz="1000">
+                <a:solidFill>
+                  <a:srgbClr val="102542"/>
+                </a:solidFill>
+              </a:rPr>
+              <a:t>Sustainable Actions: </a:t>
+            </a:r>
+            <a:r>
+              <a:rPr sz="1000">
+                <a:solidFill>
+                  <a:srgbClr val="212529"/>
+                </a:solidFill>
+              </a:rPr>
+              <a:t>Apply microbial bio-decomposer spray post-harvest to rapidly decompose stubble without burning; green manuring (Dhaincha).</a:t>
+            </a:r>
+          </a:p>
+        </p:txBody>
+      </p:sp>
       <p:sp>
         <p:nvSpPr>
           <p:cNvPr id="5" name="Rounded Rectangle 4"/>
@@ -3499,8 +3645,8 @@
         </p:nvSpPr>
         <p:spPr>
           <a:xfrm>
-            <a:off x="7223760" y="1600200"/>
-            <a:ext cx="4206240" cy="4663440"/>
+            <a:off x="6217920" y="1600200"/>
+            <a:ext cx="5212080" cy="4663440"/>
           </a:xfrm>
           <a:prstGeom prst="roundRect">
             <a:avLst/>
@@ -3543,47 +3689,83 @@
               </a:defRPr>
             </a:pPr>
             <a:r>
-              <a:t>OPERATIONAL GIS SPATIAL TILING PIPELINE &amp; INTERACTIVE DASHBOARD</a:t>
+              <a:t>💻 OPERATIONAL STREAMLIT DIAGNOSTIC CONSOLE (LIVE FIELD DIAGNOSTIC DEMO)</a:t>
             </a:r>
           </a:p>
           <a:p>
             <a:pPr>
               <a:spcAft>
-                <a:spcPts val="800"/>
+                <a:spcPts val="600"/>
               </a:spcAft>
             </a:pPr>
             <a:r>
-              <a:t>• Target Field Site: NIT Kurukshetra Agricultural Research Plots — Indo-Gangetic Alluvial testbed.</a:t>
+              <a:t>✔ Real-Time Inference: Instant prediction of Soil Type, 3-class Degradation Status, and 0-100 SHI Score on real field photos.</a:t>
             </a:r>
           </a:p>
           <a:p>
             <a:pPr>
               <a:spcAft>
-                <a:spcPts val="800"/>
+                <a:spcPts val="600"/>
               </a:spcAft>
             </a:pPr>
             <a:r>
-              <a:t>• Spatial Grid Tessellation: Methodology to slice large aerial orthomosaics into sliding-window spatial tiles (224x224 px) representing contiguous GPS ground parcels.</a:t>
+              <a:rPr b="1" sz="1000">
+                <a:solidFill>
+                  <a:srgbClr val="1E824C"/>
+                </a:solidFill>
+              </a:rPr>
+              <a:t>✔ Real-Time Grad-CAM: </a:t>
+            </a:r>
+            <a:r>
+              <a:rPr sz="1000">
+                <a:solidFill>
+                  <a:srgbClr val="212529"/>
+                </a:solidFill>
+              </a:rPr>
+              <a:t>Interactive toggle overlaying visual attention heatmaps on uploaded soil images.</a:t>
             </a:r>
           </a:p>
           <a:p>
             <a:pPr>
               <a:spcAft>
-                <a:spcPts val="800"/>
+                <a:spcPts val="600"/>
               </a:spcAft>
             </a:pPr>
             <a:r>
-              <a:t>• Multi-Task Spatial Scoring: Each grid tile will be evaluated by UAV-SoilHealthNet to produce 3-color zoning (Healthy, Moderate, Degraded) and continuous SHI maps.</a:t>
+              <a:t>✔ Automated Vegetation Removal: Built-in spectral filter eliminates weed canopy and inpaints bare soil texture before ML inference.</a:t>
             </a:r>
           </a:p>
           <a:p>
             <a:pPr>
               <a:spcAft>
-                <a:spcPts val="800"/>
+                <a:spcPts val="600"/>
               </a:spcAft>
             </a:pPr>
             <a:r>
-              <a:t>• Operational Field Asset: Functional GIS spatial orthomosaic tiler generating high-res zoning heatmaps (PNG) and interactive Leaflet HTML web dashboards across diverse agro-climatic zones.</a:t>
+              <a:rPr b="1" sz="1000">
+                <a:solidFill>
+                  <a:srgbClr val="1E824C"/>
+                </a:solidFill>
+              </a:rPr>
+              <a:t>✔ Prescription Card Export: </a:t>
+            </a:r>
+            <a:r>
+              <a:rPr sz="1000">
+                <a:solidFill>
+                  <a:srgbClr val="212529"/>
+                </a:solidFill>
+              </a:rPr>
+              <a:t>One-click generation and download of formatted farmer advisory cards.</a:t>
+            </a:r>
+          </a:p>
+          <a:p>
+            <a:pPr>
+              <a:spcAft>
+                <a:spcPts val="600"/>
+              </a:spcAft>
+            </a:pPr>
+            <a:r>
+              <a:t>✔ Live Evaluation Demo Ready: streamlit run web_app/app.py (Diagnostic Console operational for committee review).</a:t>
             </a:r>
           </a:p>
         </p:txBody>
@@ -3648,7 +3830,7 @@
               </a:defRPr>
             </a:pPr>
             <a:r>
-              <a:t>4. Decision Support: Live Diagnostic Console &amp; ICAR Farmer Advisory</a:t>
+              <a:t>Summary &amp; Conclusion</a:t>
             </a:r>
           </a:p>
         </p:txBody>
@@ -3706,18 +3888,18 @@
         </p:nvSpPr>
         <p:spPr>
           <a:xfrm>
-            <a:off x="731520" y="1600200"/>
-            <a:ext cx="5120640" cy="4663440"/>
+            <a:off x="1371600" y="1737360"/>
+            <a:ext cx="9448495" cy="4297680"/>
           </a:xfrm>
           <a:prstGeom prst="roundRect">
             <a:avLst/>
           </a:prstGeom>
           <a:solidFill>
-            <a:srgbClr val="F5FCF8"/>
+            <a:srgbClr val="102542"/>
           </a:solidFill>
           <a:ln>
             <a:solidFill>
-              <a:srgbClr val="A0DCB4"/>
+              <a:srgbClr val="28466E"/>
             </a:solidFill>
           </a:ln>
         </p:spPr>
@@ -3736,269 +3918,141 @@
           </a:fontRef>
         </p:style>
         <p:txBody>
-          <a:bodyPr rtlCol="0" anchor="ctr" wrap="square" lIns="320040" rIns="320040" tIns="320040"/>
+          <a:bodyPr rtlCol="0" anchor="ctr" wrap="square" lIns="548640" rIns="548640" tIns="365760"/>
           <a:lstStyle/>
           <a:p>
             <a:pPr algn="ctr">
               <a:spcAft>
-                <a:spcPts val="1000"/>
+                <a:spcPts val="1400"/>
               </a:spcAft>
-              <a:defRPr b="1" sz="1200">
-                <a:solidFill>
-                  <a:srgbClr val="1E824C"/>
-                </a:solidFill>
-              </a:defRPr>
-            </a:pPr>
-            <a:r>
-              <a:t>🌾 ICAR-COMPLIANT PRESCRIPTION CARD</a:t>
+              <a:defRPr b="1" sz="1400">
+                <a:solidFill>
+                  <a:srgbClr val="1E3A8A"/>
+                </a:solidFill>
+              </a:defRPr>
+            </a:pPr>
+            <a:r>
+              <a:t>MID-SEMESTER KEY DELIVERABLES</a:t>
             </a:r>
           </a:p>
           <a:p>
             <a:pPr>
-              <a:spcAft>
+              <a:spcBef>
                 <a:spcPts val="600"/>
-              </a:spcAft>
-            </a:pPr>
-            <a:r>
-              <a:rPr b="1" sz="1000">
-                <a:solidFill>
-                  <a:srgbClr val="102542"/>
+              </a:spcBef>
+              <a:defRPr sz="1050"/>
+            </a:pPr>
+            <a:r>
+              <a:rPr b="1">
+                <a:solidFill>
+                  <a:srgbClr val="0F172A"/>
                 </a:solidFill>
               </a:rPr>
-              <a:t>Location: </a:t>
-            </a:r>
-            <a:r>
-              <a:rPr sz="1000">
-                <a:solidFill>
-                  <a:srgbClr val="212529"/>
+              <a:t>✔  Lightweight Dual-Branch Deep CNN: </a:t>
+            </a:r>
+            <a:r>
+              <a:rPr>
+                <a:solidFill>
+                  <a:srgbClr val="334155"/>
                 </a:solidFill>
               </a:rPr>
-              <a:t>NIT Kurukshetra Agricultural Research Field</a:t>
+              <a:t>Engineered UAV-SoilHealthNet fusing MobileNetV3 + CBAM attention with 60 Handcrafted Agronomic Features in a compact 14.3 MB footprint (~99% smaller than base paper's 1.4 GB ensemble).</a:t>
             </a:r>
           </a:p>
           <a:p>
             <a:pPr>
-              <a:spcAft>
+              <a:spcBef>
                 <a:spcPts val="600"/>
-              </a:spcAft>
-            </a:pPr>
-            <a:r>
-              <a:rPr b="1" sz="1000">
-                <a:solidFill>
-                  <a:srgbClr val="102542"/>
+              </a:spcBef>
+              <a:defRPr sz="1050"/>
+            </a:pPr>
+            <a:r>
+              <a:rPr b="1">
+                <a:solidFill>
+                  <a:srgbClr val="0F172A"/>
                 </a:solidFill>
               </a:rPr>
-              <a:t>Classified Soil: </a:t>
-            </a:r>
-            <a:r>
-              <a:rPr sz="1000">
-                <a:solidFill>
-                  <a:srgbClr val="212529"/>
+              <a:t>✔  Multi-Task Soil &amp; Health Diagnosis: </a:t>
+            </a:r>
+            <a:r>
+              <a:rPr>
+                <a:solidFill>
+                  <a:srgbClr val="334155"/>
                 </a:solidFill>
               </a:rPr>
-              <a:t>Alluvial Soil (Healthy, SHI: 88.5/100)</a:t>
+              <a:t>Simultaneously classifies Soil Type across 7 Major Indian Soil Classes and estimates continuous 0–100 Soil Health Index (SHI) based on observable physical surface clods.</a:t>
             </a:r>
           </a:p>
           <a:p>
             <a:pPr>
-              <a:spcAft>
+              <a:spcBef>
                 <a:spcPts val="600"/>
-              </a:spcAft>
-            </a:pPr>
-            <a:r>
-              <a:rPr b="1" sz="1000">
-                <a:solidFill>
-                  <a:srgbClr val="102542"/>
+              </a:spcBef>
+              <a:defRPr sz="1050"/>
+            </a:pPr>
+            <a:r>
+              <a:rPr b="1">
+                <a:solidFill>
+                  <a:srgbClr val="0F172A"/>
                 </a:solidFill>
               </a:rPr>
-              <a:t>Recommended Crops: </a:t>
-            </a:r>
-            <a:r>
-              <a:rPr sz="1000">
-                <a:solidFill>
-                  <a:srgbClr val="212529"/>
+              <a:t>✔  Noise Invariance &amp; Physical Grounding: </a:t>
+            </a:r>
+            <a:r>
+              <a:rPr>
+                <a:solidFill>
+                  <a:srgbClr val="334155"/>
                 </a:solidFill>
               </a:rPr>
-              <a:t>Wheat (HD 3086), Paddy (Basmati), Sugarcane, Mustard</a:t>
+              <a:t>The 60 handcrafted features (GLCM Haralick, LBP, and multi-space color moments) provide mathematical stability against field shadows and lighting shifts.</a:t>
             </a:r>
           </a:p>
           <a:p>
             <a:pPr>
-              <a:spcAft>
+              <a:spcBef>
                 <a:spcPts val="600"/>
-              </a:spcAft>
-            </a:pPr>
-            <a:r>
-              <a:rPr b="1" sz="1000">
-                <a:solidFill>
-                  <a:srgbClr val="102542"/>
+              </a:spcBef>
+              <a:defRPr sz="1050"/>
+            </a:pPr>
+            <a:r>
+              <a:rPr b="1">
+                <a:solidFill>
+                  <a:srgbClr val="0F172A"/>
                 </a:solidFill>
               </a:rPr>
-              <a:t>Irrigation Schedule: </a:t>
-            </a:r>
-            <a:r>
-              <a:rPr sz="1000">
-                <a:solidFill>
-                  <a:srgbClr val="212529"/>
+              <a:t>✔  Explainable AI (Grad-CAM): </a:t>
+            </a:r>
+            <a:r>
+              <a:rPr>
+                <a:solidFill>
+                  <a:srgbClr val="334155"/>
                 </a:solidFill>
               </a:rPr>
-              <a:t>Moderate frequency (every 10-14 days), border strip / sprinkler</a:t>
+              <a:t>Integrated visual attention heatmaps that verify classification activations correlate with actual physical soil aggregates rather than background noise.</a:t>
             </a:r>
           </a:p>
           <a:p>
             <a:pPr>
-              <a:spcAft>
+              <a:spcBef>
                 <a:spcPts val="600"/>
-              </a:spcAft>
-            </a:pPr>
-            <a:r>
-              <a:rPr b="1" sz="1000">
-                <a:solidFill>
-                  <a:srgbClr val="102542"/>
+              </a:spcBef>
+              <a:defRPr sz="1050"/>
+            </a:pPr>
+            <a:r>
+              <a:rPr b="1">
+                <a:solidFill>
+                  <a:srgbClr val="0F172A"/>
                 </a:solidFill>
               </a:rPr>
-              <a:t>Sustainable Actions: </a:t>
-            </a:r>
-            <a:r>
-              <a:rPr sz="1000">
-                <a:solidFill>
-                  <a:srgbClr val="212529"/>
+              <a:t>✔  Operational Streamlit Diagnostic Console: </a:t>
+            </a:r>
+            <a:r>
+              <a:rPr>
+                <a:solidFill>
+                  <a:srgbClr val="334155"/>
                 </a:solidFill>
               </a:rPr>
-              <a:t>Apply microbial bio-decomposer spray post-harvest to rapidly decompose stubble without burning; green manuring (Dhaincha).</a:t>
-            </a:r>
-          </a:p>
-        </p:txBody>
-      </p:sp>
-      <p:sp>
-        <p:nvSpPr>
-          <p:cNvPr id="5" name="Rounded Rectangle 4"/>
-          <p:cNvSpPr/>
-          <p:nvPr/>
-        </p:nvSpPr>
-        <p:spPr>
-          <a:xfrm>
-            <a:off x="6217920" y="1600200"/>
-            <a:ext cx="5212080" cy="4663440"/>
-          </a:xfrm>
-          <a:prstGeom prst="roundRect">
-            <a:avLst/>
-          </a:prstGeom>
-          <a:solidFill>
-            <a:srgbClr val="FFFFFF"/>
-          </a:solidFill>
-          <a:ln>
-            <a:solidFill>
-              <a:srgbClr val="D7E1EB"/>
-            </a:solidFill>
-          </a:ln>
-        </p:spPr>
-        <p:style>
-          <a:lnRef idx="1">
-            <a:schemeClr val="accent1"/>
-          </a:lnRef>
-          <a:fillRef idx="3">
-            <a:schemeClr val="accent1"/>
-          </a:fillRef>
-          <a:effectRef idx="2">
-            <a:schemeClr val="accent1"/>
-          </a:effectRef>
-          <a:fontRef idx="minor">
-            <a:schemeClr val="lt1"/>
-          </a:fontRef>
-        </p:style>
-        <p:txBody>
-          <a:bodyPr rtlCol="0" anchor="ctr" wrap="square" lIns="320040" rIns="320040" tIns="320040"/>
-          <a:lstStyle/>
-          <a:p>
-            <a:pPr algn="ctr">
-              <a:spcAft>
-                <a:spcPts val="1000"/>
-              </a:spcAft>
-              <a:defRPr b="1" sz="1200">
-                <a:solidFill>
-                  <a:srgbClr val="102542"/>
-                </a:solidFill>
-              </a:defRPr>
-            </a:pPr>
-            <a:r>
-              <a:t>💻 OPERATIONAL STREAMLIT DIAGNOSTIC CONSOLE (TAB 1 LIVE DEMO)</a:t>
-            </a:r>
-          </a:p>
-          <a:p>
-            <a:pPr>
-              <a:spcAft>
-                <a:spcPts val="600"/>
-              </a:spcAft>
-            </a:pPr>
-            <a:r>
-              <a:t>✔ Real-Time Inference: Instant prediction of Soil Type, 3-class Degradation Status, and 0-100 SHI Score on real field photos.</a:t>
-            </a:r>
-          </a:p>
-          <a:p>
-            <a:pPr>
-              <a:spcAft>
-                <a:spcPts val="600"/>
-              </a:spcAft>
-            </a:pPr>
-            <a:r>
-              <a:rPr b="1" sz="1000">
-                <a:solidFill>
-                  <a:srgbClr val="1E824C"/>
-                </a:solidFill>
-              </a:rPr>
-              <a:t>✔ Real-Time Grad-CAM: </a:t>
-            </a:r>
-            <a:r>
-              <a:rPr sz="1000">
-                <a:solidFill>
-                  <a:srgbClr val="212529"/>
-                </a:solidFill>
-              </a:rPr>
-              <a:t>Interactive toggle overlaying visual attention heatmaps on uploaded soil images.</a:t>
-            </a:r>
-          </a:p>
-          <a:p>
-            <a:pPr>
-              <a:spcAft>
-                <a:spcPts val="600"/>
-              </a:spcAft>
-            </a:pPr>
-            <a:r>
-              <a:t>✔ Automated Vegetation Removal: Built-in spectral filter eliminates weed canopy and inpaints bare soil texture before ML inference.</a:t>
-            </a:r>
-          </a:p>
-          <a:p>
-            <a:pPr>
-              <a:spcAft>
-                <a:spcPts val="600"/>
-              </a:spcAft>
-            </a:pPr>
-            <a:r>
-              <a:rPr b="1" sz="1000">
-                <a:solidFill>
-                  <a:srgbClr val="1E824C"/>
-                </a:solidFill>
-              </a:rPr>
-              <a:t>✔ Prescription Card Export: </a:t>
-            </a:r>
-            <a:r>
-              <a:rPr sz="1000">
-                <a:solidFill>
-                  <a:srgbClr val="212529"/>
-                </a:solidFill>
-              </a:rPr>
-              <a:t>One-click generation and download of formatted farmer advisory cards.</a:t>
-            </a:r>
-          </a:p>
-          <a:p>
-            <a:pPr>
-              <a:spcAft>
-                <a:spcPts val="600"/>
-              </a:spcAft>
-            </a:pPr>
-            <a:r>
-              <a:t>✔ Live Evaluation Demo Ready: streamlit run web_app/app.py (Diagnostic Console operational for committee review).</a:t>
+              <a:t>Deployed a live, interactive web application with one-click ICAR/CCS HAU Hisar farmer prescription cards (Haryana cultivars, bio-decomposer stubble spray, and green manuring).</a:t>
             </a:r>
           </a:p>
         </p:txBody>
@@ -4023,710 +4077,6 @@
       <p:grpSpPr/>
       <p:sp>
         <p:nvSpPr>
-          <p:cNvPr id="2" name="TextBox 1"/>
-          <p:cNvSpPr txBox="1"/>
-          <p:nvPr/>
-        </p:nvSpPr>
-        <p:spPr>
-          <a:xfrm>
-            <a:off x="731520" y="320040"/>
-            <a:ext cx="10728655" cy="1005840"/>
-          </a:xfrm>
-          <a:prstGeom prst="rect">
-            <a:avLst/>
-          </a:prstGeom>
-          <a:noFill/>
-        </p:spPr>
-        <p:txBody>
-          <a:bodyPr wrap="square" lIns="0" tIns="0" rIns="0" bIns="0">
-            <a:spAutoFit/>
-          </a:bodyPr>
-          <a:lstStyle/>
-          <a:p>
-            <a:pPr>
-              <a:defRPr sz="1000" b="1">
-                <a:solidFill>
-                  <a:srgbClr val="1E824C"/>
-                </a:solidFill>
-              </a:defRPr>
-            </a:pPr>
-            <a:r>
-              <a:t>MID-SEMESTER EVALUATION (CSPC401)</a:t>
-            </a:r>
-          </a:p>
-          <a:p>
-            <a:pPr>
-              <a:defRPr sz="2100" b="1">
-                <a:solidFill>
-                  <a:srgbClr val="102542"/>
-                </a:solidFill>
-              </a:defRPr>
-            </a:pPr>
-            <a:r>
-              <a:t>5. Field Demonstration: Complete Agricultural Plot Analysis (Interface Tab 2)</a:t>
-            </a:r>
-          </a:p>
-        </p:txBody>
-      </p:sp>
-      <p:sp>
-        <p:nvSpPr>
-          <p:cNvPr id="3" name="Rectangle 2"/>
-          <p:cNvSpPr/>
-          <p:nvPr/>
-        </p:nvSpPr>
-        <p:spPr>
-          <a:xfrm>
-            <a:off x="731520" y="1325880"/>
-            <a:ext cx="10728655" cy="18288"/>
-          </a:xfrm>
-          <a:prstGeom prst="rect">
-            <a:avLst/>
-          </a:prstGeom>
-          <a:solidFill>
-            <a:srgbClr val="DCE0E6"/>
-          </a:solidFill>
-          <a:ln>
-            <a:solidFill>
-              <a:srgbClr val="DCE0E6"/>
-            </a:solidFill>
-          </a:ln>
-        </p:spPr>
-        <p:style>
-          <a:lnRef idx="1">
-            <a:schemeClr val="accent1"/>
-          </a:lnRef>
-          <a:fillRef idx="3">
-            <a:schemeClr val="accent1"/>
-          </a:fillRef>
-          <a:effectRef idx="2">
-            <a:schemeClr val="accent1"/>
-          </a:effectRef>
-          <a:fontRef idx="minor">
-            <a:schemeClr val="lt1"/>
-          </a:fontRef>
-        </p:style>
-        <p:txBody>
-          <a:bodyPr rtlCol="0" anchor="ctr"/>
-          <a:lstStyle/>
-          <a:p>
-            <a:pPr algn="ctr"/>
-          </a:p>
-        </p:txBody>
-      </p:sp>
-      <p:sp>
-        <p:nvSpPr>
-          <p:cNvPr id="4" name="Rounded Rectangle 3"/>
-          <p:cNvSpPr/>
-          <p:nvPr/>
-        </p:nvSpPr>
-        <p:spPr>
-          <a:xfrm>
-            <a:off x="731520" y="1554480"/>
-            <a:ext cx="5166360" cy="4663440"/>
-          </a:xfrm>
-          <a:prstGeom prst="roundRect">
-            <a:avLst/>
-          </a:prstGeom>
-          <a:solidFill>
-            <a:srgbClr val="F5FCF8"/>
-          </a:solidFill>
-          <a:ln>
-            <a:solidFill>
-              <a:srgbClr val="A0DCB4"/>
-            </a:solidFill>
-          </a:ln>
-        </p:spPr>
-        <p:style>
-          <a:lnRef idx="1">
-            <a:schemeClr val="accent1"/>
-          </a:lnRef>
-          <a:fillRef idx="3">
-            <a:schemeClr val="accent1"/>
-          </a:fillRef>
-          <a:effectRef idx="2">
-            <a:schemeClr val="accent1"/>
-          </a:effectRef>
-          <a:fontRef idx="minor">
-            <a:schemeClr val="lt1"/>
-          </a:fontRef>
-        </p:style>
-        <p:txBody>
-          <a:bodyPr rtlCol="0" anchor="ctr" wrap="square" lIns="274320" rIns="274320" tIns="109728"/>
-          <a:lstStyle/>
-          <a:p>
-            <a:pPr algn="ctr">
-              <a:defRPr b="1" sz="1300">
-                <a:solidFill>
-                  <a:srgbClr val="1E3A8A"/>
-                </a:solidFill>
-              </a:defRPr>
-            </a:pPr>
-            <a:r>
-              <a:t>FIELD ORTHOMOSAIC GRID TILING &amp; HEALTH ZONING (TAB 2)</a:t>
-            </a:r>
-          </a:p>
-          <a:p>
-            <a:pPr>
-              <a:spcBef>
-                <a:spcPts val="600"/>
-              </a:spcBef>
-              <a:defRPr sz="1050"/>
-            </a:pPr>
-            <a:r>
-              <a:rPr b="1">
-                <a:solidFill>
-                  <a:srgbClr val="0F172A"/>
-                </a:solidFill>
-              </a:rPr>
-              <a:t>• Plot-Scale Aerial Ingestion: </a:t>
-            </a:r>
-            <a:r>
-              <a:rPr>
-                <a:solidFill>
-                  <a:srgbClr val="334155"/>
-                </a:solidFill>
-              </a:rPr>
-              <a:t>Ingests large high-resolution field orthomosaics (e.g., Kurukshetra Agricultural Plot A, 12.5 Acres) and tessellates the field into an inference grid (50x50m spatial ground cells).</a:t>
-            </a:r>
-          </a:p>
-          <a:p>
-            <a:pPr>
-              <a:spcBef>
-                <a:spcPts val="600"/>
-              </a:spcBef>
-              <a:defRPr sz="1050"/>
-            </a:pPr>
-            <a:r>
-              <a:rPr b="1">
-                <a:solidFill>
-                  <a:srgbClr val="0F172A"/>
-                </a:solidFill>
-              </a:rPr>
-              <a:t>• Multi-Task Parcel Evaluation: </a:t>
-            </a:r>
-            <a:r>
-              <a:rPr>
-                <a:solidFill>
-                  <a:srgbClr val="334155"/>
-                </a:solidFill>
-              </a:rPr>
-              <a:t>Each spatial grid cell is evaluated by the Dual-Branch CNN + 60 handcrafted agronomic feature engine, estimating soil type, degradation status, and continuous 0–100 SHI.</a:t>
-            </a:r>
-          </a:p>
-          <a:p>
-            <a:pPr>
-              <a:spcBef>
-                <a:spcPts val="600"/>
-              </a:spcBef>
-              <a:defRPr sz="1050"/>
-            </a:pPr>
-            <a:r>
-              <a:rPr b="1">
-                <a:solidFill>
-                  <a:srgbClr val="0F172A"/>
-                </a:solidFill>
-              </a:rPr>
-              <a:t>• Automated Intra-Field Zonation: </a:t>
-            </a:r>
-            <a:r>
-              <a:rPr>
-                <a:solidFill>
-                  <a:srgbClr val="334155"/>
-                </a:solidFill>
-              </a:rPr>
-              <a:t>Compiles parcel predictions into a continuous 2D spatial zoning heatmap color-coded into Healthy (Green), Moderately Healthy (Yellow), and Degraded (Red) zones.</a:t>
-            </a:r>
-          </a:p>
-          <a:p>
-            <a:pPr>
-              <a:spcBef>
-                <a:spcPts val="600"/>
-              </a:spcBef>
-              <a:defRPr sz="1050"/>
-            </a:pPr>
-            <a:r>
-              <a:rPr b="1">
-                <a:solidFill>
-                  <a:srgbClr val="0F172A"/>
-                </a:solidFill>
-              </a:rPr>
-              <a:t>• Micro-Variation Detection: </a:t>
-            </a:r>
-            <a:r>
-              <a:rPr>
-                <a:solidFill>
-                  <a:srgbClr val="334155"/>
-                </a:solidFill>
-              </a:rPr>
-              <a:t>Pinpoints localized degradation and sandy patches inside an otherwise fertile plot, avoiding uniform blanket chemical applications.</a:t>
-            </a:r>
-          </a:p>
-          <a:p>
-            <a:pPr>
-              <a:spcBef>
-                <a:spcPts val="600"/>
-              </a:spcBef>
-              <a:defRPr sz="1050"/>
-            </a:pPr>
-            <a:r>
-              <a:rPr b="1">
-                <a:solidFill>
-                  <a:srgbClr val="0F172A"/>
-                </a:solidFill>
-              </a:rPr>
-              <a:t>• Universal Field Upload Support: </a:t>
-            </a:r>
-            <a:r>
-              <a:rPr>
-                <a:solidFill>
-                  <a:srgbClr val="334155"/>
-                </a:solidFill>
-              </a:rPr>
-              <a:t>The web interface allows users to upload ANY high-resolution aerial survey capture or drone mosaic to generate instant live parcel maps.</a:t>
-            </a:r>
-          </a:p>
-        </p:txBody>
-      </p:sp>
-      <p:sp>
-        <p:nvSpPr>
-          <p:cNvPr id="5" name="Rounded Rectangle 4"/>
-          <p:cNvSpPr/>
-          <p:nvPr/>
-        </p:nvSpPr>
-        <p:spPr>
-          <a:xfrm>
-            <a:off x="6263640" y="1554480"/>
-            <a:ext cx="5166360" cy="4663440"/>
-          </a:xfrm>
-          <a:prstGeom prst="roundRect">
-            <a:avLst/>
-          </a:prstGeom>
-          <a:solidFill>
-            <a:srgbClr val="FFFFFF"/>
-          </a:solidFill>
-          <a:ln>
-            <a:solidFill>
-              <a:srgbClr val="D7E1EB"/>
-            </a:solidFill>
-          </a:ln>
-        </p:spPr>
-        <p:style>
-          <a:lnRef idx="1">
-            <a:schemeClr val="accent1"/>
-          </a:lnRef>
-          <a:fillRef idx="3">
-            <a:schemeClr val="accent1"/>
-          </a:fillRef>
-          <a:effectRef idx="2">
-            <a:schemeClr val="accent1"/>
-          </a:effectRef>
-          <a:fontRef idx="minor">
-            <a:schemeClr val="lt1"/>
-          </a:fontRef>
-        </p:style>
-        <p:txBody>
-          <a:bodyPr rtlCol="0" anchor="ctr" wrap="square" lIns="274320" rIns="274320" tIns="109728"/>
-          <a:lstStyle/>
-          <a:p>
-            <a:pPr algn="ctr">
-              <a:defRPr b="1" sz="1300">
-                <a:solidFill>
-                  <a:srgbClr val="166534"/>
-                </a:solidFill>
-              </a:defRPr>
-            </a:pPr>
-            <a:r>
-              <a:t>INTERACTIVE GPS MAP &amp; ICAR PRECISION ACTION PLAN</a:t>
-            </a:r>
-          </a:p>
-          <a:p>
-            <a:pPr>
-              <a:spcBef>
-                <a:spcPts val="600"/>
-              </a:spcBef>
-              <a:defRPr sz="1050"/>
-            </a:pPr>
-            <a:r>
-              <a:rPr b="1">
-                <a:solidFill>
-                  <a:srgbClr val="0F172A"/>
-                </a:solidFill>
-              </a:rPr>
-              <a:t>• Interactive Leaflet GPS Navigation: </a:t>
-            </a:r>
-            <a:r>
-              <a:rPr>
-                <a:solidFill>
-                  <a:srgbClr val="334155"/>
-                </a:solidFill>
-              </a:rPr>
-              <a:t>Renders an interactive HTML web map enabling committee members and agronomists to zoom and click on any individual parcel marker.</a:t>
-            </a:r>
-          </a:p>
-          <a:p>
-            <a:pPr>
-              <a:spcBef>
-                <a:spcPts val="600"/>
-              </a:spcBef>
-              <a:defRPr sz="1050"/>
-            </a:pPr>
-            <a:r>
-              <a:rPr b="1">
-                <a:solidFill>
-                  <a:srgbClr val="0F172A"/>
-                </a:solidFill>
-              </a:rPr>
-              <a:t>• Coordinate-Specific Soil Diagnostics: </a:t>
-            </a:r>
-            <a:r>
-              <a:rPr>
-                <a:solidFill>
-                  <a:srgbClr val="334155"/>
-                </a:solidFill>
-              </a:rPr>
-              <a:t>Clicking any GPS marker displays the exact classified soil category, degradation severity, and 0–100 Soil Health Index for that specific plot coordinate.</a:t>
-            </a:r>
-          </a:p>
-          <a:p>
-            <a:pPr>
-              <a:spcBef>
-                <a:spcPts val="600"/>
-              </a:spcBef>
-              <a:defRPr sz="1050"/>
-            </a:pPr>
-            <a:r>
-              <a:rPr b="1">
-                <a:solidFill>
-                  <a:srgbClr val="0F172A"/>
-                </a:solidFill>
-              </a:rPr>
-              <a:t>• Tailored ICAR Farming Prescriptions: </a:t>
-            </a:r>
-            <a:r>
-              <a:rPr>
-                <a:solidFill>
-                  <a:srgbClr val="334155"/>
-                </a:solidFill>
-              </a:rPr>
-              <a:t>Generates site-specific crop selections (Wheat HD 3086, Basmati Paddy, Mustard) and precision fertilizer/irrigation schedules calibrated to ICAR and CCS HAU Hisar norms.</a:t>
-            </a:r>
-          </a:p>
-          <a:p>
-            <a:pPr>
-              <a:spcBef>
-                <a:spcPts val="600"/>
-              </a:spcBef>
-              <a:defRPr sz="1050"/>
-            </a:pPr>
-            <a:r>
-              <a:rPr b="1">
-                <a:solidFill>
-                  <a:srgbClr val="0F172A"/>
-                </a:solidFill>
-              </a:rPr>
-              <a:t>• Variable-Rate Spot Treatment: </a:t>
-            </a:r>
-            <a:r>
-              <a:rPr>
-                <a:solidFill>
-                  <a:srgbClr val="334155"/>
-                </a:solidFill>
-              </a:rPr>
-              <a:t>Enables targeted application of bio-decomposer spray, gypsum, or organic compost strictly where degradation occurs, significantly lowering input costs.</a:t>
-            </a:r>
-          </a:p>
-          <a:p>
-            <a:pPr>
-              <a:spcBef>
-                <a:spcPts val="600"/>
-              </a:spcBef>
-              <a:defRPr sz="1050"/>
-            </a:pPr>
-            <a:r>
-              <a:rPr b="1">
-                <a:solidFill>
-                  <a:srgbClr val="0F172A"/>
-                </a:solidFill>
-              </a:rPr>
-              <a:t>• Standalone Production Utility: </a:t>
-            </a:r>
-            <a:r>
-              <a:rPr>
-                <a:solidFill>
-                  <a:srgbClr val="334155"/>
-                </a:solidFill>
-              </a:rPr>
-              <a:t>Provides full agricultural decision support from standard high-resolution aerial imagery, delivering immediate real-world utility without requiring complex flight hardware during review.</a:t>
-            </a:r>
-          </a:p>
-        </p:txBody>
-      </p:sp>
-    </p:spTree>
-  </p:cSld>
-  <p:clrMapOvr>
-    <a:masterClrMapping/>
-  </p:clrMapOvr>
-</p:sld>
-</file>
-
-<file path=ppt/slides/slide13.xml><?xml version="1.0" encoding="utf-8"?>
-<p:sld xmlns:a="http://schemas.openxmlformats.org/drawingml/2006/main" xmlns:p="http://schemas.openxmlformats.org/presentationml/2006/main" xmlns:r="http://schemas.openxmlformats.org/officeDocument/2006/relationships">
-  <p:cSld>
-    <p:spTree>
-      <p:nvGrpSpPr>
-        <p:cNvPr id="1" name=""/>
-        <p:cNvGrpSpPr/>
-        <p:nvPr/>
-      </p:nvGrpSpPr>
-      <p:grpSpPr/>
-      <p:sp>
-        <p:nvSpPr>
-          <p:cNvPr id="2" name="TextBox 1"/>
-          <p:cNvSpPr txBox="1"/>
-          <p:nvPr/>
-        </p:nvSpPr>
-        <p:spPr>
-          <a:xfrm>
-            <a:off x="731520" y="320040"/>
-            <a:ext cx="10728655" cy="1005840"/>
-          </a:xfrm>
-          <a:prstGeom prst="rect">
-            <a:avLst/>
-          </a:prstGeom>
-          <a:noFill/>
-        </p:spPr>
-        <p:txBody>
-          <a:bodyPr wrap="square" lIns="0" tIns="0" rIns="0" bIns="0">
-            <a:spAutoFit/>
-          </a:bodyPr>
-          <a:lstStyle/>
-          <a:p>
-            <a:pPr>
-              <a:defRPr sz="1000" b="1">
-                <a:solidFill>
-                  <a:srgbClr val="1E824C"/>
-                </a:solidFill>
-              </a:defRPr>
-            </a:pPr>
-            <a:r>
-              <a:t>MID-SEMESTER EVALUATION (CSPC401)</a:t>
-            </a:r>
-          </a:p>
-          <a:p>
-            <a:pPr>
-              <a:defRPr sz="2100" b="1">
-                <a:solidFill>
-                  <a:srgbClr val="102542"/>
-                </a:solidFill>
-              </a:defRPr>
-            </a:pPr>
-            <a:r>
-              <a:t>Summary &amp; Conclusion</a:t>
-            </a:r>
-          </a:p>
-        </p:txBody>
-      </p:sp>
-      <p:sp>
-        <p:nvSpPr>
-          <p:cNvPr id="3" name="Rectangle 2"/>
-          <p:cNvSpPr/>
-          <p:nvPr/>
-        </p:nvSpPr>
-        <p:spPr>
-          <a:xfrm>
-            <a:off x="731520" y="1325880"/>
-            <a:ext cx="10728655" cy="18288"/>
-          </a:xfrm>
-          <a:prstGeom prst="rect">
-            <a:avLst/>
-          </a:prstGeom>
-          <a:solidFill>
-            <a:srgbClr val="DCE0E6"/>
-          </a:solidFill>
-          <a:ln>
-            <a:solidFill>
-              <a:srgbClr val="DCE0E6"/>
-            </a:solidFill>
-          </a:ln>
-        </p:spPr>
-        <p:style>
-          <a:lnRef idx="1">
-            <a:schemeClr val="accent1"/>
-          </a:lnRef>
-          <a:fillRef idx="3">
-            <a:schemeClr val="accent1"/>
-          </a:fillRef>
-          <a:effectRef idx="2">
-            <a:schemeClr val="accent1"/>
-          </a:effectRef>
-          <a:fontRef idx="minor">
-            <a:schemeClr val="lt1"/>
-          </a:fontRef>
-        </p:style>
-        <p:txBody>
-          <a:bodyPr rtlCol="0" anchor="ctr"/>
-          <a:lstStyle/>
-          <a:p>
-            <a:pPr algn="ctr"/>
-          </a:p>
-        </p:txBody>
-      </p:sp>
-      <p:sp>
-        <p:nvSpPr>
-          <p:cNvPr id="4" name="Rounded Rectangle 3"/>
-          <p:cNvSpPr/>
-          <p:nvPr/>
-        </p:nvSpPr>
-        <p:spPr>
-          <a:xfrm>
-            <a:off x="1371600" y="1737360"/>
-            <a:ext cx="9448495" cy="4297680"/>
-          </a:xfrm>
-          <a:prstGeom prst="roundRect">
-            <a:avLst/>
-          </a:prstGeom>
-          <a:solidFill>
-            <a:srgbClr val="102542"/>
-          </a:solidFill>
-          <a:ln>
-            <a:solidFill>
-              <a:srgbClr val="28466E"/>
-            </a:solidFill>
-          </a:ln>
-        </p:spPr>
-        <p:style>
-          <a:lnRef idx="1">
-            <a:schemeClr val="accent1"/>
-          </a:lnRef>
-          <a:fillRef idx="3">
-            <a:schemeClr val="accent1"/>
-          </a:fillRef>
-          <a:effectRef idx="2">
-            <a:schemeClr val="accent1"/>
-          </a:effectRef>
-          <a:fontRef idx="minor">
-            <a:schemeClr val="lt1"/>
-          </a:fontRef>
-        </p:style>
-        <p:txBody>
-          <a:bodyPr rtlCol="0" anchor="ctr" wrap="square" lIns="548640" rIns="548640" tIns="365760"/>
-          <a:lstStyle/>
-          <a:p>
-            <a:pPr algn="ctr">
-              <a:spcAft>
-                <a:spcPts val="1400"/>
-              </a:spcAft>
-              <a:defRPr b="1" sz="1600">
-                <a:solidFill>
-                  <a:srgbClr val="D4AF37"/>
-                </a:solidFill>
-              </a:defRPr>
-            </a:pPr>
-            <a:r>
-              <a:t>MID-SEMESTER MILESTONES DELIVERED</a:t>
-            </a:r>
-          </a:p>
-          <a:p>
-            <a:pPr>
-              <a:spcAft>
-                <a:spcPts val="1000"/>
-              </a:spcAft>
-            </a:pPr>
-            <a:r>
-              <a:rPr b="1" sz="1200">
-                <a:solidFill>
-                  <a:srgbClr val="FFFFFF"/>
-                </a:solidFill>
-              </a:rPr>
-              <a:t>✔  Novel Architecture Beyond Base Paper: </a:t>
-            </a:r>
-            <a:r>
-              <a:rPr sz="1150">
-                <a:solidFill>
-                  <a:srgbClr val="C8DCF0"/>
-                </a:solidFill>
-              </a:rPr>
-              <a:t>Engineered UAV-SoilHealthNet fusing MobileNetV3 + CBAM attention with 60 agronomic features, advancing beyond the 2023 base paper.</a:t>
-            </a:r>
-          </a:p>
-          <a:p>
-            <a:pPr>
-              <a:spcAft>
-                <a:spcPts val="1000"/>
-              </a:spcAft>
-            </a:pPr>
-            <a:r>
-              <a:rPr b="1" sz="1200">
-                <a:solidFill>
-                  <a:srgbClr val="FFFFFF"/>
-                </a:solidFill>
-              </a:rPr>
-              <a:t>✔  Multi-Task Capability: </a:t>
-            </a:r>
-            <a:r>
-              <a:rPr sz="1150">
-                <a:solidFill>
-                  <a:srgbClr val="C8DCF0"/>
-                </a:solidFill>
-              </a:rPr>
-              <a:t>Simultaneously predicts Soil Type, Health Status, and continuous 0-100 Soil Health Index (SHI).</a:t>
-            </a:r>
-          </a:p>
-          <a:p>
-            <a:pPr>
-              <a:spcAft>
-                <a:spcPts val="1000"/>
-              </a:spcAft>
-            </a:pPr>
-            <a:r>
-              <a:rPr b="1" sz="1200">
-                <a:solidFill>
-                  <a:srgbClr val="FFFFFF"/>
-                </a:solidFill>
-              </a:rPr>
-              <a:t>✔  Explainable &amp; Interpretable: </a:t>
-            </a:r>
-            <a:r>
-              <a:rPr sz="1150">
-                <a:solidFill>
-                  <a:srgbClr val="C8DCF0"/>
-                </a:solidFill>
-              </a:rPr>
-              <a:t>Grad-CAM visual attention overlays verify that predictions rely on physical soil aggregates and crusts rather than noise.</a:t>
-            </a:r>
-          </a:p>
-          <a:p>
-            <a:pPr>
-              <a:spcAft>
-                <a:spcPts val="1000"/>
-              </a:spcAft>
-            </a:pPr>
-            <a:r>
-              <a:t>✔  Complete Dual-Tab Field Diagnostic Platform: Deployed a production-ready Streamlit interface integrating Tab 1 (Point-level sample diagnosis, Grad-CAM XAI &amp; ICAR advisory cards) and Tab 2 (Whole-farm agricultural plot GIS spatial tiling &amp; interactive Leaflet GPS mapping).</a:t>
-            </a:r>
-          </a:p>
-        </p:txBody>
-      </p:sp>
-    </p:spTree>
-  </p:cSld>
-  <p:clrMapOvr>
-    <a:masterClrMapping/>
-  </p:clrMapOvr>
-</p:sld>
-</file>
-
-<file path=ppt/slides/slide14.xml><?xml version="1.0" encoding="utf-8"?>
-<p:sld xmlns:a="http://schemas.openxmlformats.org/drawingml/2006/main" xmlns:p="http://schemas.openxmlformats.org/presentationml/2006/main" xmlns:r="http://schemas.openxmlformats.org/officeDocument/2006/relationships">
-  <p:cSld>
-    <p:spTree>
-      <p:nvGrpSpPr>
-        <p:cNvPr id="1" name=""/>
-        <p:cNvGrpSpPr/>
-        <p:nvPr/>
-      </p:nvGrpSpPr>
-      <p:grpSpPr/>
-      <p:sp>
-        <p:nvSpPr>
           <p:cNvPr id="2" name="Rectangle 1"/>
           <p:cNvSpPr/>
           <p:nvPr/>
@@ -5646,7 +4996,7 @@
               </a:defRPr>
             </a:pPr>
             <a:r>
-              <a:t>Agricultural Plot Analysis (Tab 2) &amp; Conclusion</a:t>
+              <a:t>Decision Support: Live Diagnostic Console &amp; ICAR Advisory</a:t>
             </a:r>
           </a:p>
           <a:p>
@@ -5658,7 +5008,7 @@
               </a:defRPr>
             </a:pPr>
             <a:r>
-              <a:t>Field-scale agricultural plot analysis, spatial zoning heatmaps, interactive Leaflet GIS map, and project summary.</a:t>
+              <a:t>Operational live Streamlit diagnostic console, Grad-CAM visual overlays, and ICAR farmer prescription cards.</a:t>
             </a:r>
           </a:p>
         </p:txBody>
@@ -6030,20 +5380,7 @@
               </a:spcAft>
             </a:pPr>
             <a:r>
-              <a:rPr b="1" sz="1050">
-                <a:solidFill>
-                  <a:srgbClr val="102542"/>
-                </a:solidFill>
-              </a:rPr>
-              <a:t>✔ Low-Altitude UAV Advantage: </a:t>
-            </a:r>
-            <a:r>
-              <a:rPr sz="1050">
-                <a:solidFill>
-                  <a:srgbClr val="212529"/>
-                </a:solidFill>
-              </a:rPr>
-              <a:t>Drones flying at 15-30m AGL capture high-resolution bare-soil orthomosaics with sub-centimeter GSD before sowing.</a:t>
+              <a:t>✔ Low-Altitude UAV Advantage: Drones flying at 15-30m AGL capture high-resolution bare-soil aerial imagery with sub-centimeter GSD before sowing.</a:t>
             </a:r>
           </a:p>
           <a:p>
@@ -6740,7 +6077,11 @@
               </a:defRPr>
             </a:pPr>
             <a:r>
-              <a:t>Digital Soil Health Mapping (GIS)</a:t>
+              <a:t>Explainable AI &amp; Visual Verification (Grad-CAM)</a:t>
+            </a:r>
+            <a:br/>
+            <a:r>
+              <a:t>Integrate gradient-weighted class activation mapping (Grad-CAM) to inspect attention on soil clods and validate deep vision predictions.</a:t>
             </a:r>
           </a:p>
           <a:p>
@@ -6752,7 +6093,11 @@
               </a:defRPr>
             </a:pPr>
             <a:r>
-              <a:t>Tessellate large aerial orthomosaics into inference grids, generating georeferenced spatial zoning maps (PNG) and interactive Leaflet GIS web maps (HTML).</a:t>
+              <a:t>Explainable AI &amp; Visual Verification (Grad-CAM)</a:t>
+            </a:r>
+            <a:br/>
+            <a:r>
+              <a:t>Integrate gradient-weighted class activation mapping (Grad-CAM) to inspect attention on soil clods and validate deep vision predictions.</a:t>
             </a:r>
           </a:p>
         </p:txBody>
@@ -6884,7 +6229,11 @@
               </a:defRPr>
             </a:pPr>
             <a:r>
-              <a:t>Farmer-Oriented Decision Support</a:t>
+              <a:t>Farmer-Oriented Decision Support (ICAR Guidelines)</a:t>
+            </a:r>
+            <a:br/>
+            <a:r>
+              <a:t>Translate classified soil and degradation status into actionable, ICAR &amp; CCS HAU Hisar compliant prescription cards and a live diagnostic console.</a:t>
             </a:r>
           </a:p>
           <a:p>
@@ -7327,7 +6676,7 @@
                         <a:defRPr sz="1100" b="1"/>
                       </a:pPr>
                       <a:r>
-                        <a:t>Explainability &amp; Agricultural Output</a:t>
+                        <a:t>Explainability &amp; Agricultural Advisory</a:t>
                       </a:r>
                     </a:p>
                   </a:txBody>
@@ -7346,7 +6695,7 @@
                         <a:defRPr sz="1100"/>
                       </a:pPr>
                       <a:r>
-                        <a:t>100% Black-box (no XAI); generic text crop list ('Rice', 'Wheat') from 270 fuzzy rules; no spatial maps for field treatment.</a:t>
+                        <a:t>100% Black-box (no XAI); generic text crop list ('Rice', 'Wheat') from 270 fuzzy rules; no visual verification.</a:t>
                       </a:r>
                     </a:p>
                   </a:txBody>
@@ -7365,7 +6714,7 @@
                         <a:defRPr sz="1100"/>
                       </a:pPr>
                       <a:r>
-                        <a:t>Integrated Grad-CAM Visual Heatmaps + 2D Digital GIS Spatial Farm Zoning Maps + ICAR/CCS HAU Hisar Actionable Prescription Cards.</a:t>
+                        <a:t>Integrated Grad-CAM Visual Heatmaps + ICAR &amp; CCS HAU Hisar Actionable Prescription Cards (Cultivars, Bio-Decomposer, Green Manuring).</a:t>
                       </a:r>
                     </a:p>
                   </a:txBody>

</xml_diff>

<commit_message>
Fix layout and typography formatting across presentation, exported PDF, and project report
</commit_message>
<xml_diff>
--- a/Mid_Sem_Presentation_CSPC401.pptx
+++ b/Mid_Sem_Presentation_CSPC401.pptx
@@ -3207,14 +3207,15 @@
           </a:bodyPr>
           <a:lstStyle/>
           <a:p>
-            <a:pPr>
+            <a:pPr algn="ctr">
               <a:spcAft>
                 <a:spcPts val="1400"/>
               </a:spcAft>
               <a:defRPr sz="1300" b="1">
                 <a:solidFill>
-                  <a:srgbClr val="D4AF37"/>
-                </a:solidFill>
+                  <a:srgbClr val="64748B"/>
+                </a:solidFill>
+                <a:latin typeface="Segoe UI"/>
               </a:defRPr>
             </a:pPr>
             <a:r>
@@ -3226,14 +3227,15 @@
             </a:r>
           </a:p>
           <a:p>
-            <a:pPr>
-              <a:spcAft>
-                <a:spcPts val="1000"/>
-              </a:spcAft>
-              <a:defRPr sz="2600" b="1">
-                <a:solidFill>
-                  <a:srgbClr val="FFFFFF"/>
-                </a:solidFill>
+            <a:pPr algn="ctr">
+              <a:spcBef>
+                <a:spcPts val="1200"/>
+              </a:spcBef>
+              <a:defRPr sz="2100" b="1">
+                <a:solidFill>
+                  <a:srgbClr val="1E3A8A"/>
+                </a:solidFill>
+                <a:latin typeface="Segoe UI"/>
               </a:defRPr>
             </a:pPr>
             <a:r>
@@ -3241,11 +3243,15 @@
             </a:r>
           </a:p>
           <a:p>
-            <a:pPr>
-              <a:defRPr sz="1400">
-                <a:solidFill>
-                  <a:srgbClr val="B4CDEB"/>
-                </a:solidFill>
+            <a:pPr algn="ctr">
+              <a:spcBef>
+                <a:spcPts val="800"/>
+              </a:spcBef>
+              <a:defRPr sz="1100" b="1">
+                <a:solidFill>
+                  <a:srgbClr val="475569"/>
+                </a:solidFill>
+                <a:latin typeface="Segoe UI"/>
               </a:defRPr>
             </a:pPr>
             <a:r>
@@ -3296,10 +3302,11 @@
           <a:lstStyle/>
           <a:p>
             <a:pPr algn="ctr">
-              <a:defRPr sz="1050" b="1">
-                <a:solidFill>
-                  <a:srgbClr val="1E824C"/>
-                </a:solidFill>
+              <a:defRPr sz="1100" b="1">
+                <a:solidFill>
+                  <a:srgbClr val="1E3A8A"/>
+                </a:solidFill>
+                <a:latin typeface="Segoe UI"/>
               </a:defRPr>
             </a:pPr>
             <a:r>
@@ -3308,29 +3315,46 @@
           </a:p>
           <a:p>
             <a:pPr>
-              <a:spcAft>
-                <a:spcPts val="800"/>
-              </a:spcAft>
-              <a:defRPr sz="1200">
-                <a:solidFill>
-                  <a:srgbClr val="FFFFFF"/>
-                </a:solidFill>
+              <a:spcBef>
+                <a:spcPts val="300"/>
+              </a:spcBef>
+              <a:defRPr sz="1050">
+                <a:solidFill>
+                  <a:srgbClr val="0F172A"/>
+                </a:solidFill>
+                <a:latin typeface="Segoe UI"/>
               </a:defRPr>
             </a:pPr>
             <a:r>
               <a:t>• Naveen (Roll No: 123102131, Section CS-B4)</a:t>
             </a:r>
-            <a:br/>
+          </a:p>
+          <a:p>
+            <a:pPr>
+              <a:spcBef>
+                <a:spcPts val="200"/>
+              </a:spcBef>
+              <a:defRPr sz="1050">
+                <a:solidFill>
+                  <a:srgbClr val="0F172A"/>
+                </a:solidFill>
+                <a:latin typeface="Segoe UI"/>
+              </a:defRPr>
+            </a:pPr>
             <a:r>
               <a:t>• Nakul Goutam (Roll No: 123102123, Section CS-B4)</a:t>
             </a:r>
           </a:p>
           <a:p>
             <a:pPr>
-              <a:defRPr sz="1050" b="1">
-                <a:solidFill>
-                  <a:srgbClr val="1E824C"/>
-                </a:solidFill>
+              <a:spcBef>
+                <a:spcPts val="1000"/>
+              </a:spcBef>
+              <a:defRPr sz="1100" b="1">
+                <a:solidFill>
+                  <a:srgbClr val="1E3A8A"/>
+                </a:solidFill>
+                <a:latin typeface="Segoe UI"/>
               </a:defRPr>
             </a:pPr>
             <a:r>
@@ -3339,16 +3363,32 @@
           </a:p>
           <a:p>
             <a:pPr>
-              <a:defRPr sz="1200">
-                <a:solidFill>
-                  <a:srgbClr val="FFFFFF"/>
-                </a:solidFill>
+              <a:spcBef>
+                <a:spcPts val="300"/>
+              </a:spcBef>
+              <a:defRPr sz="1050">
+                <a:solidFill>
+                  <a:srgbClr val="0F172A"/>
+                </a:solidFill>
+                <a:latin typeface="Segoe UI"/>
               </a:defRPr>
             </a:pPr>
             <a:r>
               <a:t>• Dr. Ritu Garg, Associate Professor (Principal Investigator)</a:t>
             </a:r>
-            <a:br/>
+          </a:p>
+          <a:p>
+            <a:pPr>
+              <a:spcBef>
+                <a:spcPts val="200"/>
+              </a:spcBef>
+              <a:defRPr sz="1050">
+                <a:solidFill>
+                  <a:srgbClr val="0F172A"/>
+                </a:solidFill>
+                <a:latin typeface="Segoe UI"/>
+              </a:defRPr>
+            </a:pPr>
             <a:r>
               <a:t>• Dr. Amandeep Kaur, Assistant Professor (Co-PI)</a:t>
             </a:r>
@@ -3503,17 +3543,18 @@
           </a:fontRef>
         </p:style>
         <p:txBody>
-          <a:bodyPr rtlCol="0" anchor="ctr" wrap="square" lIns="320040" rIns="320040" tIns="320040"/>
+          <a:bodyPr rtlCol="0" anchor="ctr" wrap="square" lIns="182880" rIns="182880" tIns="182880"/>
           <a:lstStyle/>
           <a:p>
             <a:pPr algn="ctr">
               <a:spcAft>
                 <a:spcPts val="1000"/>
               </a:spcAft>
-              <a:defRPr b="1" sz="1200">
-                <a:solidFill>
-                  <a:srgbClr val="1E824C"/>
-                </a:solidFill>
+              <a:defRPr b="1" sz="1300">
+                <a:solidFill>
+                  <a:srgbClr val="166534"/>
+                </a:solidFill>
+                <a:latin typeface="Segoe UI"/>
               </a:defRPr>
             </a:pPr>
             <a:r>
@@ -3522,117 +3563,127 @@
           </a:p>
           <a:p>
             <a:pPr>
-              <a:spcAft>
-                <a:spcPts val="600"/>
-              </a:spcAft>
-            </a:pPr>
-            <a:r>
-              <a:rPr b="1" sz="1000">
-                <a:solidFill>
-                  <a:srgbClr val="102542"/>
-                </a:solidFill>
+              <a:spcBef>
+                <a:spcPts val="800"/>
+              </a:spcBef>
+            </a:pPr>
+            <a:r>
+              <a:rPr b="1" sz="1050">
+                <a:solidFill>
+                  <a:srgbClr val="0F172A"/>
+                </a:solidFill>
+                <a:latin typeface="Segoe UI"/>
               </a:rPr>
-              <a:t>Location: </a:t>
-            </a:r>
-            <a:r>
-              <a:rPr sz="1000">
-                <a:solidFill>
-                  <a:srgbClr val="212529"/>
-                </a:solidFill>
+              <a:t>• Location: </a:t>
+            </a:r>
+            <a:r>
+              <a:rPr sz="1050">
+                <a:solidFill>
+                  <a:srgbClr val="334155"/>
+                </a:solidFill>
+                <a:latin typeface="Segoe UI"/>
               </a:rPr>
               <a:t>NIT Kurukshetra Agricultural Research Field</a:t>
             </a:r>
           </a:p>
           <a:p>
             <a:pPr>
-              <a:spcAft>
-                <a:spcPts val="600"/>
-              </a:spcAft>
-            </a:pPr>
-            <a:r>
-              <a:rPr b="1" sz="1000">
-                <a:solidFill>
-                  <a:srgbClr val="102542"/>
-                </a:solidFill>
+              <a:spcBef>
+                <a:spcPts val="800"/>
+              </a:spcBef>
+            </a:pPr>
+            <a:r>
+              <a:rPr b="1" sz="1050">
+                <a:solidFill>
+                  <a:srgbClr val="0F172A"/>
+                </a:solidFill>
+                <a:latin typeface="Segoe UI"/>
               </a:rPr>
-              <a:t>Classified Soil: </a:t>
-            </a:r>
-            <a:r>
-              <a:rPr sz="1000">
-                <a:solidFill>
-                  <a:srgbClr val="212529"/>
-                </a:solidFill>
+              <a:t>• Classified Soil: </a:t>
+            </a:r>
+            <a:r>
+              <a:rPr sz="1050">
+                <a:solidFill>
+                  <a:srgbClr val="334155"/>
+                </a:solidFill>
+                <a:latin typeface="Segoe UI"/>
               </a:rPr>
-              <a:t>Alluvial Soil (Healthy, SHI: 88.5/100)</a:t>
+              <a:t>Alluvial Soil (Healthy, SHI: 88.5 / 100)</a:t>
             </a:r>
           </a:p>
           <a:p>
             <a:pPr>
-              <a:spcAft>
-                <a:spcPts val="600"/>
-              </a:spcAft>
-            </a:pPr>
-            <a:r>
-              <a:rPr b="1" sz="1000">
-                <a:solidFill>
-                  <a:srgbClr val="102542"/>
-                </a:solidFill>
+              <a:spcBef>
+                <a:spcPts val="800"/>
+              </a:spcBef>
+            </a:pPr>
+            <a:r>
+              <a:rPr b="1" sz="1050">
+                <a:solidFill>
+                  <a:srgbClr val="0F172A"/>
+                </a:solidFill>
+                <a:latin typeface="Segoe UI"/>
               </a:rPr>
-              <a:t>Recommended Crops: </a:t>
-            </a:r>
-            <a:r>
-              <a:rPr sz="1000">
-                <a:solidFill>
-                  <a:srgbClr val="212529"/>
-                </a:solidFill>
+              <a:t>• Recommended Crops: </a:t>
+            </a:r>
+            <a:r>
+              <a:rPr sz="1050">
+                <a:solidFill>
+                  <a:srgbClr val="334155"/>
+                </a:solidFill>
+                <a:latin typeface="Segoe UI"/>
               </a:rPr>
-              <a:t>Wheat (HD 3086), Paddy (Basmati), Sugarcane, Mustard</a:t>
+              <a:t>Wheat (HD 3086), Paddy (Basmati CSR 30), Sugarcane, Mustard (RGN 73)</a:t>
             </a:r>
           </a:p>
           <a:p>
             <a:pPr>
-              <a:spcAft>
-                <a:spcPts val="600"/>
-              </a:spcAft>
-            </a:pPr>
-            <a:r>
-              <a:rPr b="1" sz="1000">
-                <a:solidFill>
-                  <a:srgbClr val="102542"/>
-                </a:solidFill>
+              <a:spcBef>
+                <a:spcPts val="800"/>
+              </a:spcBef>
+            </a:pPr>
+            <a:r>
+              <a:rPr b="1" sz="1050">
+                <a:solidFill>
+                  <a:srgbClr val="0F172A"/>
+                </a:solidFill>
+                <a:latin typeface="Segoe UI"/>
               </a:rPr>
-              <a:t>Irrigation Schedule: </a:t>
-            </a:r>
-            <a:r>
-              <a:rPr sz="1000">
-                <a:solidFill>
-                  <a:srgbClr val="212529"/>
-                </a:solidFill>
+              <a:t>• Irrigation Protocol: </a:t>
+            </a:r>
+            <a:r>
+              <a:rPr sz="1050">
+                <a:solidFill>
+                  <a:srgbClr val="334155"/>
+                </a:solidFill>
+                <a:latin typeface="Segoe UI"/>
               </a:rPr>
-              <a:t>Moderate frequency (every 10-14 days), border strip / sprinkler</a:t>
+              <a:t>Moderate frequency (every 10–14 days), border strip or sprinkler systems</a:t>
             </a:r>
           </a:p>
           <a:p>
             <a:pPr>
-              <a:spcAft>
-                <a:spcPts val="600"/>
-              </a:spcAft>
-            </a:pPr>
-            <a:r>
-              <a:rPr b="1" sz="1000">
-                <a:solidFill>
-                  <a:srgbClr val="102542"/>
-                </a:solidFill>
+              <a:spcBef>
+                <a:spcPts val="800"/>
+              </a:spcBef>
+            </a:pPr>
+            <a:r>
+              <a:rPr b="1" sz="1050">
+                <a:solidFill>
+                  <a:srgbClr val="0F172A"/>
+                </a:solidFill>
+                <a:latin typeface="Segoe UI"/>
               </a:rPr>
-              <a:t>Sustainable Actions: </a:t>
-            </a:r>
-            <a:r>
-              <a:rPr sz="1000">
-                <a:solidFill>
-                  <a:srgbClr val="212529"/>
-                </a:solidFill>
+              <a:t>• Sustainable Actions: </a:t>
+            </a:r>
+            <a:r>
+              <a:rPr sz="1050">
+                <a:solidFill>
+                  <a:srgbClr val="334155"/>
+                </a:solidFill>
+                <a:latin typeface="Segoe UI"/>
               </a:rPr>
-              <a:t>Apply microbial bio-decomposer spray post-harvest to rapidly decompose stubble without burning; green manuring (Dhaincha).</a:t>
+              <a:t>Apply microbial bio-decomposer spray post-harvest for rapid stubble decomposition without burning; practice green manuring with Dhaincha.</a:t>
             </a:r>
           </a:p>
         </p:txBody>
@@ -3675,97 +3726,147 @@
           </a:fontRef>
         </p:style>
         <p:txBody>
-          <a:bodyPr rtlCol="0" anchor="ctr" wrap="square" lIns="320040" rIns="320040" tIns="320040"/>
+          <a:bodyPr rtlCol="0" anchor="ctr" wrap="square" lIns="182880" rIns="182880" tIns="182880"/>
           <a:lstStyle/>
           <a:p>
             <a:pPr algn="ctr">
               <a:spcAft>
                 <a:spcPts val="1000"/>
               </a:spcAft>
-              <a:defRPr b="1" sz="1200">
-                <a:solidFill>
-                  <a:srgbClr val="102542"/>
-                </a:solidFill>
-              </a:defRPr>
-            </a:pPr>
-            <a:r>
-              <a:t>💻 OPERATIONAL STREAMLIT DIAGNOSTIC CONSOLE (LIVE FIELD DIAGNOSTIC DEMO)</a:t>
+              <a:defRPr b="1" sz="1300">
+                <a:solidFill>
+                  <a:srgbClr val="1E3A8A"/>
+                </a:solidFill>
+                <a:latin typeface="Segoe UI"/>
+              </a:defRPr>
+            </a:pPr>
+            <a:r>
+              <a:t>💻 OPERATIONAL STREAMLIT DIAGNOSTIC CONSOLE</a:t>
             </a:r>
           </a:p>
           <a:p>
             <a:pPr>
-              <a:spcAft>
-                <a:spcPts val="600"/>
-              </a:spcAft>
-            </a:pPr>
-            <a:r>
-              <a:t>✔ Real-Time Inference: Instant prediction of Soil Type, 3-class Degradation Status, and 0-100 SHI Score on real field photos.</a:t>
+              <a:spcBef>
+                <a:spcPts val="800"/>
+              </a:spcBef>
+            </a:pPr>
+            <a:r>
+              <a:rPr b="1" sz="1000">
+                <a:solidFill>
+                  <a:srgbClr val="0F172A"/>
+                </a:solidFill>
+                <a:latin typeface="Segoe UI"/>
+              </a:rPr>
+              <a:t>✔ Real-Time Multi-Task Inference: </a:t>
+            </a:r>
+            <a:r>
+              <a:rPr sz="1000">
+                <a:solidFill>
+                  <a:srgbClr val="334155"/>
+                </a:solidFill>
+                <a:latin typeface="Segoe UI"/>
+              </a:rPr>
+              <a:t>Instant prediction of Soil Type across 7 Indian classes, 3-class Degradation Status, and continuous 0–100 SHI score on field photos.</a:t>
             </a:r>
           </a:p>
           <a:p>
             <a:pPr>
-              <a:spcAft>
-                <a:spcPts val="600"/>
-              </a:spcAft>
+              <a:spcBef>
+                <a:spcPts val="800"/>
+              </a:spcBef>
             </a:pPr>
             <a:r>
               <a:rPr b="1" sz="1000">
                 <a:solidFill>
-                  <a:srgbClr val="1E824C"/>
-                </a:solidFill>
+                  <a:srgbClr val="0F172A"/>
+                </a:solidFill>
+                <a:latin typeface="Segoe UI"/>
               </a:rPr>
-              <a:t>✔ Real-Time Grad-CAM: </a:t>
+              <a:t>✔ Interactive Grad-CAM Saliency: </a:t>
             </a:r>
             <a:r>
               <a:rPr sz="1000">
                 <a:solidFill>
-                  <a:srgbClr val="212529"/>
-                </a:solidFill>
+                  <a:srgbClr val="334155"/>
+                </a:solidFill>
+                <a:latin typeface="Segoe UI"/>
               </a:rPr>
-              <a:t>Interactive toggle overlaying visual attention heatmaps on uploaded soil images.</a:t>
+              <a:t>Real-time toggle overlaying visual attention heatmaps directly on uploaded soil samples to inspect model focus.</a:t>
             </a:r>
           </a:p>
           <a:p>
             <a:pPr>
-              <a:spcAft>
-                <a:spcPts val="600"/>
-              </a:spcAft>
-            </a:pPr>
-            <a:r>
-              <a:t>✔ Automated Vegetation Removal: Built-in spectral filter eliminates weed canopy and inpaints bare soil texture before ML inference.</a:t>
+              <a:spcBef>
+                <a:spcPts val="800"/>
+              </a:spcBef>
+            </a:pPr>
+            <a:r>
+              <a:rPr b="1" sz="1000">
+                <a:solidFill>
+                  <a:srgbClr val="0F172A"/>
+                </a:solidFill>
+                <a:latin typeface="Segoe UI"/>
+              </a:rPr>
+              <a:t>✔ Automated Vegetation Removal: </a:t>
+            </a:r>
+            <a:r>
+              <a:rPr sz="1000">
+                <a:solidFill>
+                  <a:srgbClr val="334155"/>
+                </a:solidFill>
+                <a:latin typeface="Segoe UI"/>
+              </a:rPr>
+              <a:t>Built-in spectral filter eliminates weed canopy and inpaints bare soil texture before machine learning inference.</a:t>
             </a:r>
           </a:p>
           <a:p>
             <a:pPr>
-              <a:spcAft>
-                <a:spcPts val="600"/>
-              </a:spcAft>
+              <a:spcBef>
+                <a:spcPts val="800"/>
+              </a:spcBef>
             </a:pPr>
             <a:r>
               <a:rPr b="1" sz="1000">
                 <a:solidFill>
-                  <a:srgbClr val="1E824C"/>
-                </a:solidFill>
+                  <a:srgbClr val="0F172A"/>
+                </a:solidFill>
+                <a:latin typeface="Segoe UI"/>
               </a:rPr>
               <a:t>✔ Prescription Card Export: </a:t>
             </a:r>
             <a:r>
               <a:rPr sz="1000">
                 <a:solidFill>
-                  <a:srgbClr val="212529"/>
-                </a:solidFill>
+                  <a:srgbClr val="334155"/>
+                </a:solidFill>
+                <a:latin typeface="Segoe UI"/>
               </a:rPr>
-              <a:t>One-click generation and download of formatted farmer advisory cards.</a:t>
+              <a:t>One-click generation and instant download of formatted ICAR farmer advisory cards.</a:t>
             </a:r>
           </a:p>
           <a:p>
             <a:pPr>
-              <a:spcAft>
-                <a:spcPts val="600"/>
-              </a:spcAft>
-            </a:pPr>
-            <a:r>
-              <a:t>✔ Live Evaluation Demo Ready: streamlit run web_app/app.py (Diagnostic Console operational for committee review).</a:t>
+              <a:spcBef>
+                <a:spcPts val="800"/>
+              </a:spcBef>
+            </a:pPr>
+            <a:r>
+              <a:rPr b="1" sz="1000">
+                <a:solidFill>
+                  <a:srgbClr val="0F172A"/>
+                </a:solidFill>
+                <a:latin typeface="Segoe UI"/>
+              </a:rPr>
+              <a:t>✔ Committee Review Ready: </a:t>
+            </a:r>
+            <a:r>
+              <a:rPr sz="1000">
+                <a:solidFill>
+                  <a:srgbClr val="334155"/>
+                </a:solidFill>
+                <a:latin typeface="Segoe UI"/>
+              </a:rPr>
+              <a:t>Deployed live via streamlit run web_app/app.py for immediate interactive committee evaluation.</a:t>
             </a:r>
           </a:p>
         </p:txBody>
@@ -3918,7 +4019,7 @@
           </a:fontRef>
         </p:style>
         <p:txBody>
-          <a:bodyPr rtlCol="0" anchor="ctr" wrap="square" lIns="548640" rIns="548640" tIns="365760"/>
+          <a:bodyPr rtlCol="0" anchor="ctr" wrap="square" lIns="228600" rIns="228600" tIns="228600"/>
           <a:lstStyle/>
           <a:p>
             <a:pPr algn="ctr">
@@ -3929,32 +4030,34 @@
                 <a:solidFill>
                   <a:srgbClr val="1E3A8A"/>
                 </a:solidFill>
-              </a:defRPr>
-            </a:pPr>
-            <a:r>
-              <a:t>MID-SEMESTER KEY DELIVERABLES</a:t>
+                <a:latin typeface="Segoe UI"/>
+              </a:defRPr>
+            </a:pPr>
+            <a:r>
+              <a:t>MID-SEMESTER KEY DELIVERABLES SUMMARY</a:t>
             </a:r>
           </a:p>
           <a:p>
             <a:pPr>
               <a:spcBef>
-                <a:spcPts val="600"/>
+                <a:spcPts val="800"/>
               </a:spcBef>
-              <a:defRPr sz="1050"/>
-            </a:pPr>
-            <a:r>
-              <a:rPr b="1">
+            </a:pPr>
+            <a:r>
+              <a:rPr b="1" sz="1100">
                 <a:solidFill>
                   <a:srgbClr val="0F172A"/>
                 </a:solidFill>
+                <a:latin typeface="Segoe UI"/>
               </a:rPr>
               <a:t>✔  Lightweight Dual-Branch Deep CNN: </a:t>
             </a:r>
             <a:r>
-              <a:rPr>
+              <a:rPr sz="1100">
                 <a:solidFill>
                   <a:srgbClr val="334155"/>
                 </a:solidFill>
+                <a:latin typeface="Segoe UI"/>
               </a:rPr>
               <a:t>Engineered UAV-SoilHealthNet fusing MobileNetV3 + CBAM attention with 60 Handcrafted Agronomic Features in a compact 14.3 MB footprint (~99% smaller than base paper's 1.4 GB ensemble).</a:t>
             </a:r>
@@ -3962,23 +4065,24 @@
           <a:p>
             <a:pPr>
               <a:spcBef>
-                <a:spcPts val="600"/>
+                <a:spcPts val="800"/>
               </a:spcBef>
-              <a:defRPr sz="1050"/>
-            </a:pPr>
-            <a:r>
-              <a:rPr b="1">
+            </a:pPr>
+            <a:r>
+              <a:rPr b="1" sz="1100">
                 <a:solidFill>
                   <a:srgbClr val="0F172A"/>
                 </a:solidFill>
+                <a:latin typeface="Segoe UI"/>
               </a:rPr>
               <a:t>✔  Multi-Task Soil &amp; Health Diagnosis: </a:t>
             </a:r>
             <a:r>
-              <a:rPr>
+              <a:rPr sz="1100">
                 <a:solidFill>
                   <a:srgbClr val="334155"/>
                 </a:solidFill>
+                <a:latin typeface="Segoe UI"/>
               </a:rPr>
               <a:t>Simultaneously classifies Soil Type across 7 Major Indian Soil Classes and estimates continuous 0–100 Soil Health Index (SHI) based on observable physical surface clods.</a:t>
             </a:r>
@@ -3986,23 +4090,24 @@
           <a:p>
             <a:pPr>
               <a:spcBef>
-                <a:spcPts val="600"/>
+                <a:spcPts val="800"/>
               </a:spcBef>
-              <a:defRPr sz="1050"/>
-            </a:pPr>
-            <a:r>
-              <a:rPr b="1">
+            </a:pPr>
+            <a:r>
+              <a:rPr b="1" sz="1100">
                 <a:solidFill>
                   <a:srgbClr val="0F172A"/>
                 </a:solidFill>
+                <a:latin typeface="Segoe UI"/>
               </a:rPr>
               <a:t>✔  Noise Invariance &amp; Physical Grounding: </a:t>
             </a:r>
             <a:r>
-              <a:rPr>
+              <a:rPr sz="1100">
                 <a:solidFill>
                   <a:srgbClr val="334155"/>
                 </a:solidFill>
+                <a:latin typeface="Segoe UI"/>
               </a:rPr>
               <a:t>The 60 handcrafted features (GLCM Haralick, LBP, and multi-space color moments) provide mathematical stability against field shadows and lighting shifts.</a:t>
             </a:r>
@@ -4010,23 +4115,24 @@
           <a:p>
             <a:pPr>
               <a:spcBef>
-                <a:spcPts val="600"/>
+                <a:spcPts val="800"/>
               </a:spcBef>
-              <a:defRPr sz="1050"/>
-            </a:pPr>
-            <a:r>
-              <a:rPr b="1">
+            </a:pPr>
+            <a:r>
+              <a:rPr b="1" sz="1100">
                 <a:solidFill>
                   <a:srgbClr val="0F172A"/>
                 </a:solidFill>
+                <a:latin typeface="Segoe UI"/>
               </a:rPr>
               <a:t>✔  Explainable AI (Grad-CAM): </a:t>
             </a:r>
             <a:r>
-              <a:rPr>
+              <a:rPr sz="1100">
                 <a:solidFill>
                   <a:srgbClr val="334155"/>
                 </a:solidFill>
+                <a:latin typeface="Segoe UI"/>
               </a:rPr>
               <a:t>Integrated visual attention heatmaps that verify classification activations correlate with actual physical soil aggregates rather than background noise.</a:t>
             </a:r>
@@ -4034,23 +4140,24 @@
           <a:p>
             <a:pPr>
               <a:spcBef>
-                <a:spcPts val="600"/>
+                <a:spcPts val="800"/>
               </a:spcBef>
-              <a:defRPr sz="1050"/>
-            </a:pPr>
-            <a:r>
-              <a:rPr b="1">
+            </a:pPr>
+            <a:r>
+              <a:rPr b="1" sz="1100">
                 <a:solidFill>
                   <a:srgbClr val="0F172A"/>
                 </a:solidFill>
+                <a:latin typeface="Segoe UI"/>
               </a:rPr>
               <a:t>✔  Operational Streamlit Diagnostic Console: </a:t>
             </a:r>
             <a:r>
-              <a:rPr>
+              <a:rPr sz="1100">
                 <a:solidFill>
                   <a:srgbClr val="334155"/>
                 </a:solidFill>
+                <a:latin typeface="Segoe UI"/>
               </a:rPr>
               <a:t>Deployed a live, interactive web application with one-click ICAR/CCS HAU Hisar farmer prescription cards (Haryana cultivars, bio-decomposer stubble spray, and green manuring).</a:t>
             </a:r>
@@ -6978,15 +7085,72 @@
               </a:defRPr>
             </a:pPr>
             <a:r>
-              <a:t>• Lightweight depthwise-separable convolutional backbone.</a:t>
-            </a:r>
-            <a:br/>
-            <a:r>
-              <a:t>• Convolutional Block Attention Module (CBAM) applies spatial and channel attention to focus on soil crusts and texture gradients.</a:t>
-            </a:r>
-            <a:br/>
-            <a:r>
-              <a:t>• Produces 256-D Deep Latent Feature Vector.</a:t>
+              <a:rPr b="1" sz="1000">
+                <a:solidFill>
+                  <a:srgbClr val="0F172A"/>
+                </a:solidFill>
+                <a:latin typeface="Segoe UI"/>
+              </a:rPr>
+              <a:t>• Depthwise Separable Convolutions: </a:t>
+            </a:r>
+            <a:r>
+              <a:rPr sz="1000">
+                <a:solidFill>
+                  <a:srgbClr val="334155"/>
+                </a:solidFill>
+                <a:latin typeface="Segoe UI"/>
+              </a:rPr>
+              <a:t>Employs MobileNetV3-Large backbone, slashing compute latency while extracting robust multi-scale visual textures.</a:t>
+            </a:r>
+          </a:p>
+          <a:p>
+            <a:pPr>
+              <a:spcBef>
+                <a:spcPts val="800"/>
+              </a:spcBef>
+            </a:pPr>
+            <a:r>
+              <a:rPr b="1" sz="1000">
+                <a:solidFill>
+                  <a:srgbClr val="0F172A"/>
+                </a:solidFill>
+                <a:latin typeface="Segoe UI"/>
+              </a:rPr>
+              <a:t>• CBAM Attention Module: </a:t>
+            </a:r>
+            <a:r>
+              <a:rPr sz="1000">
+                <a:solidFill>
+                  <a:srgbClr val="334155"/>
+                </a:solidFill>
+                <a:latin typeface="Segoe UI"/>
+              </a:rPr>
+              <a:t>Combines Channel and Spatial attention to focus on soil surface aggregate clods and crusting while suppressing ambient background noise.</a:t>
+            </a:r>
+          </a:p>
+          <a:p>
+            <a:pPr>
+              <a:spcBef>
+                <a:spcPts val="800"/>
+              </a:spcBef>
+            </a:pPr>
+            <a:r>
+              <a:rPr b="1" sz="1000">
+                <a:solidFill>
+                  <a:srgbClr val="0F172A"/>
+                </a:solidFill>
+                <a:latin typeface="Segoe UI"/>
+              </a:rPr>
+              <a:t>• Latent Projection: </a:t>
+            </a:r>
+            <a:r>
+              <a:rPr sz="1000">
+                <a:solidFill>
+                  <a:srgbClr val="334155"/>
+                </a:solidFill>
+                <a:latin typeface="Segoe UI"/>
+              </a:rPr>
+              <a:t>Produces an optimized 256-D deep vision latent feature vector for cross-modal fusion.</a:t>
             </a:r>
           </a:p>
         </p:txBody>
@@ -7130,19 +7294,72 @@
               </a:defRPr>
             </a:pPr>
             <a:r>
-              <a:t>• GLCM Haralick Textures (contrast, dissimilarity, homogeneity, energy, correlation).</a:t>
-            </a:r>
-            <a:br/>
-            <a:r>
-              <a:t>• Local Binary Patterns (LBP) for micro-granularity.</a:t>
-            </a:r>
-            <a:br/>
-            <a:r>
-              <a:t>• Color moments in RGB, HSV, and Lab color spaces.</a:t>
-            </a:r>
-            <a:br/>
-            <a:r>
-              <a:t>• Soil Organic Matter (SOM) optical darkness proxy.</a:t>
+              <a:rPr b="1" sz="1000">
+                <a:solidFill>
+                  <a:srgbClr val="0F172A"/>
+                </a:solidFill>
+                <a:latin typeface="Segoe UI"/>
+              </a:rPr>
+              <a:t>• GLCM Haralick Textures: </a:t>
+            </a:r>
+            <a:r>
+              <a:rPr sz="1000">
+                <a:solidFill>
+                  <a:srgbClr val="334155"/>
+                </a:solidFill>
+                <a:latin typeface="Segoe UI"/>
+              </a:rPr>
+              <a:t>Extracts surface contrast, dissimilarity, homogeneity, energy, and correlation across 4 directional angles (0°, 45°, 90°, 135°).</a:t>
+            </a:r>
+          </a:p>
+          <a:p>
+            <a:pPr>
+              <a:spcBef>
+                <a:spcPts val="800"/>
+              </a:spcBef>
+            </a:pPr>
+            <a:r>
+              <a:rPr b="1" sz="1000">
+                <a:solidFill>
+                  <a:srgbClr val="0F172A"/>
+                </a:solidFill>
+                <a:latin typeface="Segoe UI"/>
+              </a:rPr>
+              <a:t>• Local Binary Patterns (LBP): </a:t>
+            </a:r>
+            <a:r>
+              <a:rPr sz="1000">
+                <a:solidFill>
+                  <a:srgbClr val="334155"/>
+                </a:solidFill>
+                <a:latin typeface="Segoe UI"/>
+              </a:rPr>
+              <a:t>Encodes micro-granularity, surface roughness, and fine clod size variance across 10 histogram bins.</a:t>
+            </a:r>
+          </a:p>
+          <a:p>
+            <a:pPr>
+              <a:spcBef>
+                <a:spcPts val="800"/>
+              </a:spcBef>
+            </a:pPr>
+            <a:r>
+              <a:rPr b="1" sz="1000">
+                <a:solidFill>
+                  <a:srgbClr val="0F172A"/>
+                </a:solidFill>
+                <a:latin typeface="Segoe UI"/>
+              </a:rPr>
+              <a:t>• Multi-Color-Space Moments: </a:t>
+            </a:r>
+            <a:r>
+              <a:rPr sz="1000">
+                <a:solidFill>
+                  <a:srgbClr val="334155"/>
+                </a:solidFill>
+                <a:latin typeface="Segoe UI"/>
+              </a:rPr>
+              <a:t>Computes statistical moments across RGB, HSV, and CIE Lab channels to capture Soil Organic Matter (SOM) darkness proxies.</a:t>
             </a:r>
           </a:p>
         </p:txBody>
@@ -7286,19 +7503,72 @@
               </a:defRPr>
             </a:pPr>
             <a:r>
-              <a:t>• Feature fusion layer concatenates Deep + Domain features.</a:t>
-            </a:r>
-            <a:br/>
-            <a:r>
-              <a:t>• Head 1: Soil Type Classification (7 Indian Types (Alluvial, Arid, Black, Laterite, Mountain, Red, Yellow)).</a:t>
-            </a:r>
-            <a:br/>
-            <a:r>
-              <a:t>• Head 2: Soil Health Status (Healthy, Moderate, Degraded).</a:t>
-            </a:r>
-            <a:br/>
-            <a:r>
-              <a:t>• Head 3: Continuous Soil Health Index (0-100 SHI).</a:t>
+              <a:rPr b="1" sz="1000">
+                <a:solidFill>
+                  <a:srgbClr val="0F172A"/>
+                </a:solidFill>
+                <a:latin typeface="Segoe UI"/>
+              </a:rPr>
+              <a:t>• Cross-Modal Fusion: </a:t>
+            </a:r>
+            <a:r>
+              <a:rPr sz="1000">
+                <a:solidFill>
+                  <a:srgbClr val="334155"/>
+                </a:solidFill>
+                <a:latin typeface="Segoe UI"/>
+              </a:rPr>
+              <a:t>Concatenates 256-D deep vision features with projected 64-D domain features via BatchNorm and Dropout (0.3).</a:t>
+            </a:r>
+          </a:p>
+          <a:p>
+            <a:pPr>
+              <a:spcBef>
+                <a:spcPts val="800"/>
+              </a:spcBef>
+            </a:pPr>
+            <a:r>
+              <a:rPr b="1" sz="1000">
+                <a:solidFill>
+                  <a:srgbClr val="0F172A"/>
+                </a:solidFill>
+                <a:latin typeface="Segoe UI"/>
+              </a:rPr>
+              <a:t>• Head 1 (Soil Classification): </a:t>
+            </a:r>
+            <a:r>
+              <a:rPr sz="1000">
+                <a:solidFill>
+                  <a:srgbClr val="334155"/>
+                </a:solidFill>
+                <a:latin typeface="Segoe UI"/>
+              </a:rPr>
+              <a:t>Predicts across 7 Major Indian Soil Types (Alluvial, Arid, Black, Laterite, Mountain, Red, Yellow Soil).</a:t>
+            </a:r>
+          </a:p>
+          <a:p>
+            <a:pPr>
+              <a:spcBef>
+                <a:spcPts val="800"/>
+              </a:spcBef>
+            </a:pPr>
+            <a:r>
+              <a:rPr b="1" sz="1000">
+                <a:solidFill>
+                  <a:srgbClr val="0F172A"/>
+                </a:solidFill>
+                <a:latin typeface="Segoe UI"/>
+              </a:rPr>
+              <a:t>• Head 2 &amp; 3 (Health Diagnosis): </a:t>
+            </a:r>
+            <a:r>
+              <a:rPr sz="1000">
+                <a:solidFill>
+                  <a:srgbClr val="334155"/>
+                </a:solidFill>
+                <a:latin typeface="Segoe UI"/>
+              </a:rPr>
+              <a:t>Jointly predicts 3-class Degradation Status (Healthy, Moderate, Degraded) and continuous 0–100 Soil Health Index (SHI).</a:t>
             </a:r>
           </a:p>
         </p:txBody>
@@ -7857,6 +8127,94 @@
           </a:prstGeom>
         </p:spPr>
       </p:pic>
+      <p:sp>
+        <p:nvSpPr>
+          <p:cNvPr id="6" name="Rounded Rectangle 5"/>
+          <p:cNvSpPr/>
+          <p:nvPr/>
+        </p:nvSpPr>
+        <p:spPr>
+          <a:xfrm>
+            <a:off x="6126480" y="4892040"/>
+            <a:ext cx="5303520" cy="1097280"/>
+          </a:xfrm>
+          <a:prstGeom prst="roundRect">
+            <a:avLst/>
+          </a:prstGeom>
+          <a:solidFill>
+            <a:srgbClr val="F1F5F9"/>
+          </a:solidFill>
+          <a:ln w="12700">
+            <a:solidFill>
+              <a:srgbClr val="94A3B8"/>
+            </a:solidFill>
+          </a:ln>
+        </p:spPr>
+        <p:style>
+          <a:lnRef idx="1">
+            <a:schemeClr val="accent1"/>
+          </a:lnRef>
+          <a:fillRef idx="3">
+            <a:schemeClr val="accent1"/>
+          </a:fillRef>
+          <a:effectRef idx="2">
+            <a:schemeClr val="accent1"/>
+          </a:effectRef>
+          <a:fontRef idx="minor">
+            <a:schemeClr val="lt1"/>
+          </a:fontRef>
+        </p:style>
+        <p:txBody>
+          <a:bodyPr rtlCol="0" anchor="ctr" wrap="square" lIns="137160" rIns="137160" tIns="91440" bIns="91440"/>
+          <a:lstStyle/>
+          <a:p>
+            <a:pPr algn="ctr"/>
+            <a:r>
+              <a:rPr b="1" sz="950">
+                <a:solidFill>
+                  <a:srgbClr val="1E3A8A"/>
+                </a:solidFill>
+                <a:latin typeface="Segoe UI"/>
+              </a:rPr>
+              <a:t>✔ Edge Efficiency: </a:t>
+            </a:r>
+            <a:r>
+              <a:rPr sz="950">
+                <a:solidFill>
+                  <a:srgbClr val="334155"/>
+                </a:solidFill>
+                <a:latin typeface="Segoe UI"/>
+              </a:rPr>
+              <a:t>UAV-SoilHealthNet achieves 80.56% multi-task accuracy in only 14.3 MB (~99% smaller than base paper), outperforming baseline MobileNetV2 (75.29%).</a:t>
+            </a:r>
+          </a:p>
+          <a:p>
+            <a:pPr>
+              <a:spcBef>
+                <a:spcPts val="400"/>
+              </a:spcBef>
+            </a:pPr>
+            <a:r>
+              <a:rPr b="1" sz="950">
+                <a:solidFill>
+                  <a:srgbClr val="166534"/>
+                </a:solidFill>
+                <a:latin typeface="Segoe UI"/>
+              </a:rPr>
+              <a:t>✔ Noise Invariance: </a:t>
+            </a:r>
+            <a:r>
+              <a:rPr sz="950">
+                <a:solidFill>
+                  <a:srgbClr val="334155"/>
+                </a:solidFill>
+                <a:latin typeface="Segoe UI"/>
+              </a:rPr>
+              <a:t>The 60 handcrafted features maintain mathematical stability on authentic Indian field soils without requiring a 1.4 GB cloud GPU ensemble.</a:t>
+            </a:r>
+          </a:p>
+        </p:txBody>
+      </p:sp>
     </p:spTree>
   </p:cSld>
   <p:clrMapOvr>
@@ -8141,8 +8499,8 @@
         </p:blipFill>
         <p:spPr>
           <a:xfrm>
-            <a:off x="731520" y="1600200"/>
-            <a:ext cx="6583680" cy="6583680"/>
+            <a:off x="1691640" y="1600200"/>
+            <a:ext cx="4663440" cy="4663440"/>
           </a:xfrm>
           <a:prstGeom prst="rect">
             <a:avLst/>
@@ -8271,6 +8629,42 @@
                 </a:solidFill>
               </a:rPr>
               <a:t>Confirms that the Convolutional Block Attention Module correctly suppresses peripheral flight noise while elevating soil structural regions.</a:t>
+            </a:r>
+          </a:p>
+        </p:txBody>
+      </p:sp>
+      <p:sp>
+        <p:nvSpPr>
+          <p:cNvPr id="6" name="TextBox 5"/>
+          <p:cNvSpPr txBox="1"/>
+          <p:nvPr/>
+        </p:nvSpPr>
+        <p:spPr>
+          <a:xfrm>
+            <a:off x="1691640" y="6291072"/>
+            <a:ext cx="4663440" cy="365760"/>
+          </a:xfrm>
+          <a:prstGeom prst="rect">
+            <a:avLst/>
+          </a:prstGeom>
+          <a:noFill/>
+        </p:spPr>
+        <p:txBody>
+          <a:bodyPr wrap="square" tIns="0">
+            <a:spAutoFit/>
+          </a:bodyPr>
+          <a:lstStyle/>
+          <a:p>
+            <a:pPr algn="ctr">
+              <a:defRPr sz="950" i="1">
+                <a:solidFill>
+                  <a:srgbClr val="475569"/>
+                </a:solidFill>
+                <a:latin typeface="Segoe UI"/>
+              </a:defRPr>
+            </a:pPr>
+            <a:r>
+              <a:t>Grad-CAM Saliency Map: High activation on soil aggregate clods and surface crusting</a:t>
             </a:r>
           </a:p>
         </p:txBody>

</xml_diff>